<commit_message>
V3 run-1 complete: 200 epochs, holdout GO (cmd 0.9455 / slot 0.9722)
export_onnx.py: use legacy exporter (dynamo=False) to avoid onnxscript; ExportWrapper inserts channel dim so the ONNX input stays (1,80,150) matching Pi mel.py; verify at batch 1. ONNX-vs-torch parity PASS, 172 KB opset 17.

slides: fill all post-training numbers (holdout one-shot cmd 0.9455 / slot 0.9722; test cmd 0.9293 / slot 0.9748; OOS reject 11/16 holdout, 34/76 test; Pi 92ms p95 per 3s clip; 67.2k steps, epoch-142 selection, node n003). No pending cells left.
</commit_message>
<xml_diff>
--- a/slides/me2_v3_submission.pptx
+++ b/slides/me2_v3_submission.pptx
@@ -3190,7 +3190,7 @@
                 </a:solidFill>
                 <a:latin typeface="Calibri"/>
               </a:rPr>
-              <a:t>1 October 2026 · J. Lagana + AI231 ME2 group · Model · Dataset · Training on A100 · Validation on RPi 4</a:t>
+              <a:t>2 October 2026 · J. Lagana + AI231 ME2 group · Model · Dataset · Training on A100 · Validation on RPi 4</a:t>
             </a:r>
           </a:p>
         </p:txBody>
@@ -3709,7 +3709,7 @@
                           </a:solidFill>
                           <a:latin typeface="Calibri"/>
                         </a:rPr>
-                        <a:t>30,134 params · ~120 KB ONNX  (+ wake ONNX, shared mel)</a:t>
+                        <a:t>30,134 params · 172 KB ONNX (opset 17)  + wake ONNX, shared 80-mel</a:t>
                       </a:r>
                     </a:p>
                   </a:txBody>
@@ -3843,7 +3843,7 @@
                           </a:solidFill>
                           <a:latin typeface="Calibri"/>
                         </a:rPr>
-                        <a:t>Keyword / intent acc</a:t>
+                        <a:t>Command acc (holdout / test)</a:t>
                       </a:r>
                     </a:p>
                   </a:txBody>
@@ -3862,11 +3862,11 @@
                       <a:r>
                         <a:rPr sz="950" b="0">
                           <a:solidFill>
-                            <a:srgbClr val="B86A00"/>
+                            <a:srgbClr val="1A1A1A"/>
                           </a:solidFill>
                           <a:latin typeface="Calibri"/>
                         </a:rPr>
-                        <a:t>holdout ⟨cmd %⟩ / test ⟨cmd %⟩</a:t>
+                        <a:t>0.9455 / 0.9293  (holdout one-shot, 186 clips)</a:t>
                       </a:r>
                     </a:p>
                   </a:txBody>
@@ -3891,7 +3891,7 @@
                           </a:solidFill>
                           <a:latin typeface="Calibri"/>
                         </a:rPr>
-                        <a:t>False-accept rate</a:t>
+                        <a:t>Slot acc (holdout / test)</a:t>
                       </a:r>
                     </a:p>
                   </a:txBody>
@@ -3910,11 +3910,11 @@
                       <a:r>
                         <a:rPr sz="950" b="0">
                           <a:solidFill>
-                            <a:srgbClr val="B86A00"/>
+                            <a:srgbClr val="1A1A1A"/>
                           </a:solidFill>
                           <a:latin typeface="Calibri"/>
                         </a:rPr>
-                        <a:t>⟨OOS false-fire %⟩</a:t>
+                        <a:t>0.9722 / 0.9748  (slotted clips)</a:t>
                       </a:r>
                     </a:p>
                   </a:txBody>
@@ -3939,7 +3939,7 @@
                           </a:solidFill>
                           <a:latin typeface="Calibri"/>
                         </a:rPr>
-                        <a:t>Latency p95 / RTF</a:t>
+                        <a:t>OOS reject (holdout / test)</a:t>
                       </a:r>
                     </a:p>
                   </a:txBody>
@@ -3958,11 +3958,11 @@
                       <a:r>
                         <a:rPr sz="950" b="0">
                           <a:solidFill>
-                            <a:srgbClr val="B86A00"/>
+                            <a:srgbClr val="1A1A1A"/>
                           </a:solidFill>
                           <a:latin typeface="Calibri"/>
                         </a:rPr>
-                        <a:t>⟨p95 ms⟩ / ⟨RTF⟩</a:t>
+                        <a:t>11/16 (0.688) / 34/76 (0.447)  · wake gate + 0.50 conf gate in front</a:t>
                       </a:r>
                     </a:p>
                   </a:txBody>
@@ -3987,7 +3987,7 @@
                           </a:solidFill>
                           <a:latin typeface="Calibri"/>
                         </a:rPr>
-                        <a:t>Runtime</a:t>
+                        <a:t>Latency p95 / RTF (Pi 4B)</a:t>
                       </a:r>
                     </a:p>
                   </a:txBody>
@@ -4006,11 +4006,11 @@
                       <a:r>
                         <a:rPr sz="950" b="0">
                           <a:solidFill>
-                            <a:srgbClr val="B86A00"/>
+                            <a:srgbClr val="1A1A1A"/>
                           </a:solidFill>
                           <a:latin typeface="Calibri"/>
                         </a:rPr>
-                        <a:t>onnxruntime · ⟨N⟩ thr (CPU)</a:t>
+                        <a:t>92 ms / RTF 0.030  (onnxruntime CPU, 172 KB ONNX)</a:t>
                       </a:r>
                     </a:p>
                   </a:txBody>
@@ -4215,7 +4215,7 @@
                           </a:solidFill>
                           <a:latin typeface="Calibri"/>
                         </a:rPr>
-                        <a:t>81,768 clips · ≈25–30 h audio (est.)</a:t>
+                        <a:t>81,768 clips · train 10,733 / test 4,443 / holdout 202 · ≈25–30 h audio (est.)</a:t>
                       </a:r>
                     </a:p>
                   </a:txBody>
@@ -4259,11 +4259,11 @@
                       <a:r>
                         <a:rPr sz="950" b="0">
                           <a:solidFill>
-                            <a:srgbClr val="B86A00"/>
+                            <a:srgbClr val="1A1A1A"/>
                           </a:solidFill>
                           <a:latin typeface="Calibri"/>
                         </a:rPr>
-                        <a:t>N — speaker-disjoint splits</a:t>
+                        <a:t>speaker-disjoint splits · ∅ overlap verified</a:t>
                       </a:r>
                     </a:p>
                   </a:txBody>
@@ -4464,11 +4464,11 @@
                       <a:r>
                         <a:rPr sz="950" b="0">
                           <a:solidFill>
-                            <a:srgbClr val="B86A00"/>
+                            <a:srgbClr val="1A1A1A"/>
                           </a:solidFill>
                           <a:latin typeface="Calibri"/>
                         </a:rPr>
-                        <a:t>1× NVIDIA A100 · node ⟨pending⟩</a:t>
+                        <a:t>1× NVIDIA A100 · node n003 (COE HPC)</a:t>
                       </a:r>
                     </a:p>
                   </a:txBody>
@@ -4608,11 +4608,11 @@
                       <a:r>
                         <a:rPr sz="950" b="0">
                           <a:solidFill>
-                            <a:srgbClr val="B86A00"/>
+                            <a:srgbClr val="1A1A1A"/>
                           </a:solidFill>
                           <a:latin typeface="Calibri"/>
                         </a:rPr>
-                        <a:t>336 steps/epoch × 100 ≈ 33.6k steps · final loss ⟨pending⟩</a:t>
+                        <a:t>336 steps/epoch × 200 = 67.2k steps · final loss 0.206 (cmd 0.179 + slot 0.026) · best-cmd epoch 142</a:t>
                       </a:r>
                     </a:p>
                   </a:txBody>
@@ -4814,11 +4814,11 @@
                       <a:r>
                         <a:rPr sz="1050" b="0">
                           <a:solidFill>
-                            <a:srgbClr val="B86A00"/>
+                            <a:srgbClr val="1A1A1A"/>
                           </a:solidFill>
                           <a:latin typeface="Calibri"/>
                         </a:rPr>
-                        <a:t>⟨org⟩/ai231-me2-v3 — public, MIT</a:t>
+                        <a:t>github.com/jblagana/ai231-me2-v3 — public, MIT</a:t>
                       </a:r>
                     </a:p>
                   </a:txBody>
@@ -4910,11 +4910,11 @@
                       <a:r>
                         <a:rPr sz="1050" b="0">
                           <a:solidFill>
-                            <a:srgbClr val="B86A00"/>
+                            <a:srgbClr val="1A1A1A"/>
                           </a:solidFill>
                           <a:latin typeface="Calibri"/>
                         </a:rPr>
-                        <a:t>node ⟨pending⟩ · 1× A100 · wall-clock ⟨pending⟩ · seed 20261002</a:t>
+                        <a:t>node n003 · 1× A100 · wall-clock ~47 min (200 epochs, 67.2k steps) · seed 20261002</a:t>
                       </a:r>
                     </a:p>
                   </a:txBody>
@@ -4958,11 +4958,11 @@
                       <a:r>
                         <a:rPr sz="1050" b="0">
                           <a:solidFill>
-                            <a:srgbClr val="B86A00"/>
+                            <a:srgbClr val="1A1A1A"/>
                           </a:solidFill>
                           <a:latin typeface="Calibri"/>
                         </a:rPr>
-                        <a:t>⟨release URL⟩ + MIT</a:t>
+                        <a:t>me2_vcm_v3.onnx (172 KB, opset 17) · deployed live on Pi (~/me2) · MIT · released separately per repo .gitignore</a:t>
                       </a:r>
                     </a:p>
                   </a:txBody>
@@ -5162,11 +5162,11 @@
                       <a:r>
                         <a:rPr sz="950" b="1">
                           <a:solidFill>
-                            <a:srgbClr val="1F4E79"/>
+                            <a:srgbClr val="1F7A3D"/>
                           </a:solidFill>
                           <a:latin typeface="Calibri"/>
                         </a:rPr>
-                        <a:t>in progress</a:t>
+                        <a:t>yes</a:t>
                       </a:r>
                     </a:p>
                   </a:txBody>
@@ -5285,7 +5285,7 @@
                           </a:solidFill>
                           <a:latin typeface="Calibri"/>
                         </a:rPr>
-                        <a:t>Training logs + final checkpoint committed</a:t>
+                        <a:t>Training logs + final model</a:t>
                       </a:r>
                     </a:p>
                   </a:txBody>
@@ -5304,11 +5304,11 @@
                       <a:r>
                         <a:rPr sz="950" b="1">
                           <a:solidFill>
-                            <a:srgbClr val="B86A00"/>
+                            <a:srgbClr val="1F4E79"/>
                           </a:solidFill>
                           <a:latin typeface="Calibri"/>
                         </a:rPr>
-                        <a:t>pending</a:t>
+                        <a:t>released separately</a:t>
                       </a:r>
                     </a:p>
                   </a:txBody>
@@ -5375,11 +5375,11 @@
                       <a:r>
                         <a:rPr sz="950" b="1">
                           <a:solidFill>
-                            <a:srgbClr val="B86A00"/>
+                            <a:srgbClr val="1F7A3D"/>
                           </a:solidFill>
                           <a:latin typeface="Calibri"/>
                         </a:rPr>
-                        <a:t>pending</a:t>
+                        <a:t>yes</a:t>
                       </a:r>
                     </a:p>
                   </a:txBody>
@@ -5517,11 +5517,11 @@
                       <a:r>
                         <a:rPr sz="950" b="1">
                           <a:solidFill>
-                            <a:srgbClr val="B86A00"/>
+                            <a:srgbClr val="1F7A3D"/>
                           </a:solidFill>
                           <a:latin typeface="Calibri"/>
                         </a:rPr>
-                        <a:t>planned</a:t>
+                        <a:t>yes</a:t>
                       </a:r>
                     </a:p>
                   </a:txBody>

</xml_diff>

<commit_message>
Reconcile V2+V3: pi/ app (bench-logging demo, V3 model, V2 music worker + flash), models/ ONNX (md5 6271a6a9, from HPC vcm_v3), legacy/v2 archive (code+tools+hpc scripts+V2 dataset, WAVs tracked so it is available anytime), scratch/ swept, docs + submission build script committed
</commit_message>
<xml_diff>
--- a/slides/me2_v3_submission.pptx
+++ b/slides/me2_v3_submission.pptx
@@ -5,11 +5,11 @@
     <p:sldMasterId id="2147483648" r:id="rId1"/>
   </p:sldMasterIdLst>
   <p:sldIdLst>
-    <p:sldId id="256" r:id="rId7"/>
-    <p:sldId id="257" r:id="rId8"/>
-    <p:sldId id="258" r:id="rId9"/>
+    <p:sldId id="256" r:id="rId2"/>
+    <p:sldId id="257" r:id="rId3"/>
+    <p:sldId id="258" r:id="rId4"/>
   </p:sldIdLst>
-  <p:sldSz cx="12191695" cy="6858000" type="screen4x3"/>
+  <p:sldSz cx="12192000" cy="6858000"/>
   <p:notesSz cx="6858000" cy="9144000"/>
   <p:defaultTextStyle>
     <a:defPPr>
@@ -106,6 +106,22 @@
       </a:defRPr>
     </a:lvl9pPr>
   </p:defaultTextStyle>
+  <p:extLst>
+    <p:ext uri="{EFAFB233-063F-42B5-8137-9DF3F51BA10A}">
+      <p15:sldGuideLst xmlns:p15="http://schemas.microsoft.com/office/powerpoint/2012/main">
+        <p15:guide id="1" orient="horz" pos="2160">
+          <p15:clr>
+            <a:srgbClr val="A4A3A4"/>
+          </p15:clr>
+        </p15:guide>
+        <p15:guide id="2" pos="2880">
+          <p15:clr>
+            <a:srgbClr val="A4A3A4"/>
+          </p15:clr>
+        </p15:guide>
+      </p15:sldGuideLst>
+    </p:ext>
+  </p:extLst>
 </p:presentation>
 </file>
 
@@ -147,10 +163,9 @@
           <a:lstStyle/>
           <a:p>
             <a:r>
-              <a:rPr lang="en-US" smtClean="0"/>
+              <a:rPr lang="en-US"/>
               <a:t>Click to edit Master title style</a:t>
             </a:r>
-            <a:endParaRPr lang="en-US"/>
           </a:p>
         </p:txBody>
       </p:sp>
@@ -266,10 +281,9 @@
           </a:lstStyle>
           <a:p>
             <a:r>
-              <a:rPr lang="en-US" smtClean="0"/>
+              <a:rPr lang="en-US"/>
               <a:t>Click to edit Master subtitle style</a:t>
             </a:r>
-            <a:endParaRPr lang="en-US"/>
           </a:p>
         </p:txBody>
       </p:sp>
@@ -290,7 +304,7 @@
           <a:p>
             <a:fld id="{5BCAD085-E8A6-8845-BD4E-CB4CCA059FC4}" type="datetimeFigureOut">
               <a:rPr lang="en-US" smtClean="0"/>
-              <a:t>1/27/13</a:t>
+              <a:t>10/3/2026</a:t>
             </a:fld>
             <a:endParaRPr lang="en-US"/>
           </a:p>
@@ -384,10 +398,9 @@
           <a:lstStyle/>
           <a:p>
             <a:r>
-              <a:rPr lang="en-US" smtClean="0"/>
+              <a:rPr lang="en-US"/>
               <a:t>Click to edit Master title style</a:t>
             </a:r>
-            <a:endParaRPr lang="en-US"/>
           </a:p>
         </p:txBody>
       </p:sp>
@@ -408,38 +421,37 @@
           <a:p>
             <a:pPr lvl="0"/>
             <a:r>
-              <a:rPr lang="en-US" smtClean="0"/>
+              <a:rPr lang="en-US"/>
               <a:t>Click to edit Master text styles</a:t>
             </a:r>
           </a:p>
           <a:p>
             <a:pPr lvl="1"/>
             <a:r>
-              <a:rPr lang="en-US" smtClean="0"/>
+              <a:rPr lang="en-US"/>
               <a:t>Second level</a:t>
             </a:r>
           </a:p>
           <a:p>
             <a:pPr lvl="2"/>
             <a:r>
-              <a:rPr lang="en-US" smtClean="0"/>
+              <a:rPr lang="en-US"/>
               <a:t>Third level</a:t>
             </a:r>
           </a:p>
           <a:p>
             <a:pPr lvl="3"/>
             <a:r>
-              <a:rPr lang="en-US" smtClean="0"/>
+              <a:rPr lang="en-US"/>
               <a:t>Fourth level</a:t>
             </a:r>
           </a:p>
           <a:p>
             <a:pPr lvl="4"/>
             <a:r>
-              <a:rPr lang="en-US" smtClean="0"/>
+              <a:rPr lang="en-US"/>
               <a:t>Fifth level</a:t>
             </a:r>
-            <a:endParaRPr lang="en-US"/>
           </a:p>
         </p:txBody>
       </p:sp>
@@ -460,7 +472,7 @@
           <a:p>
             <a:fld id="{5BCAD085-E8A6-8845-BD4E-CB4CCA059FC4}" type="datetimeFigureOut">
               <a:rPr lang="en-US" smtClean="0"/>
-              <a:t>1/27/13</a:t>
+              <a:t>10/3/2026</a:t>
             </a:fld>
             <a:endParaRPr lang="en-US"/>
           </a:p>
@@ -559,10 +571,9 @@
           <a:lstStyle/>
           <a:p>
             <a:r>
-              <a:rPr lang="en-US" smtClean="0"/>
+              <a:rPr lang="en-US"/>
               <a:t>Click to edit Master title style</a:t>
             </a:r>
-            <a:endParaRPr lang="en-US"/>
           </a:p>
         </p:txBody>
       </p:sp>
@@ -588,38 +599,37 @@
           <a:p>
             <a:pPr lvl="0"/>
             <a:r>
-              <a:rPr lang="en-US" smtClean="0"/>
+              <a:rPr lang="en-US"/>
               <a:t>Click to edit Master text styles</a:t>
             </a:r>
           </a:p>
           <a:p>
             <a:pPr lvl="1"/>
             <a:r>
-              <a:rPr lang="en-US" smtClean="0"/>
+              <a:rPr lang="en-US"/>
               <a:t>Second level</a:t>
             </a:r>
           </a:p>
           <a:p>
             <a:pPr lvl="2"/>
             <a:r>
-              <a:rPr lang="en-US" smtClean="0"/>
+              <a:rPr lang="en-US"/>
               <a:t>Third level</a:t>
             </a:r>
           </a:p>
           <a:p>
             <a:pPr lvl="3"/>
             <a:r>
-              <a:rPr lang="en-US" smtClean="0"/>
+              <a:rPr lang="en-US"/>
               <a:t>Fourth level</a:t>
             </a:r>
           </a:p>
           <a:p>
             <a:pPr lvl="4"/>
             <a:r>
-              <a:rPr lang="en-US" smtClean="0"/>
+              <a:rPr lang="en-US"/>
               <a:t>Fifth level</a:t>
             </a:r>
-            <a:endParaRPr lang="en-US"/>
           </a:p>
         </p:txBody>
       </p:sp>
@@ -640,7 +650,7 @@
           <a:p>
             <a:fld id="{5BCAD085-E8A6-8845-BD4E-CB4CCA059FC4}" type="datetimeFigureOut">
               <a:rPr lang="en-US" smtClean="0"/>
-              <a:t>1/27/13</a:t>
+              <a:t>10/3/2026</a:t>
             </a:fld>
             <a:endParaRPr lang="en-US"/>
           </a:p>
@@ -734,10 +744,9 @@
           <a:lstStyle/>
           <a:p>
             <a:r>
-              <a:rPr lang="en-US" smtClean="0"/>
+              <a:rPr lang="en-US"/>
               <a:t>Click to edit Master title style</a:t>
             </a:r>
-            <a:endParaRPr lang="en-US"/>
           </a:p>
         </p:txBody>
       </p:sp>
@@ -758,38 +767,37 @@
           <a:p>
             <a:pPr lvl="0"/>
             <a:r>
-              <a:rPr lang="en-US" smtClean="0"/>
+              <a:rPr lang="en-US"/>
               <a:t>Click to edit Master text styles</a:t>
             </a:r>
           </a:p>
           <a:p>
             <a:pPr lvl="1"/>
             <a:r>
-              <a:rPr lang="en-US" smtClean="0"/>
+              <a:rPr lang="en-US"/>
               <a:t>Second level</a:t>
             </a:r>
           </a:p>
           <a:p>
             <a:pPr lvl="2"/>
             <a:r>
-              <a:rPr lang="en-US" smtClean="0"/>
+              <a:rPr lang="en-US"/>
               <a:t>Third level</a:t>
             </a:r>
           </a:p>
           <a:p>
             <a:pPr lvl="3"/>
             <a:r>
-              <a:rPr lang="en-US" smtClean="0"/>
+              <a:rPr lang="en-US"/>
               <a:t>Fourth level</a:t>
             </a:r>
           </a:p>
           <a:p>
             <a:pPr lvl="4"/>
             <a:r>
-              <a:rPr lang="en-US" smtClean="0"/>
+              <a:rPr lang="en-US"/>
               <a:t>Fifth level</a:t>
             </a:r>
-            <a:endParaRPr lang="en-US"/>
           </a:p>
         </p:txBody>
       </p:sp>
@@ -810,7 +818,7 @@
           <a:p>
             <a:fld id="{5BCAD085-E8A6-8845-BD4E-CB4CCA059FC4}" type="datetimeFigureOut">
               <a:rPr lang="en-US" smtClean="0"/>
-              <a:t>1/27/13</a:t>
+              <a:t>10/3/2026</a:t>
             </a:fld>
             <a:endParaRPr lang="en-US"/>
           </a:p>
@@ -913,10 +921,9 @@
           </a:lstStyle>
           <a:p>
             <a:r>
-              <a:rPr lang="en-US" smtClean="0"/>
+              <a:rPr lang="en-US"/>
               <a:t>Click to edit Master title style</a:t>
             </a:r>
-            <a:endParaRPr lang="en-US"/>
           </a:p>
         </p:txBody>
       </p:sp>
@@ -1033,7 +1040,7 @@
           <a:p>
             <a:pPr lvl="0"/>
             <a:r>
-              <a:rPr lang="en-US" smtClean="0"/>
+              <a:rPr lang="en-US"/>
               <a:t>Click to edit Master text styles</a:t>
             </a:r>
           </a:p>
@@ -1056,7 +1063,7 @@
           <a:p>
             <a:fld id="{5BCAD085-E8A6-8845-BD4E-CB4CCA059FC4}" type="datetimeFigureOut">
               <a:rPr lang="en-US" smtClean="0"/>
-              <a:t>1/27/13</a:t>
+              <a:t>10/3/2026</a:t>
             </a:fld>
             <a:endParaRPr lang="en-US"/>
           </a:p>
@@ -1150,10 +1157,9 @@
           <a:lstStyle/>
           <a:p>
             <a:r>
-              <a:rPr lang="en-US" smtClean="0"/>
+              <a:rPr lang="en-US"/>
               <a:t>Click to edit Master title style</a:t>
             </a:r>
-            <a:endParaRPr lang="en-US"/>
           </a:p>
         </p:txBody>
       </p:sp>
@@ -1207,38 +1213,37 @@
           <a:p>
             <a:pPr lvl="0"/>
             <a:r>
-              <a:rPr lang="en-US" smtClean="0"/>
+              <a:rPr lang="en-US"/>
               <a:t>Click to edit Master text styles</a:t>
             </a:r>
           </a:p>
           <a:p>
             <a:pPr lvl="1"/>
             <a:r>
-              <a:rPr lang="en-US" smtClean="0"/>
+              <a:rPr lang="en-US"/>
               <a:t>Second level</a:t>
             </a:r>
           </a:p>
           <a:p>
             <a:pPr lvl="2"/>
             <a:r>
-              <a:rPr lang="en-US" smtClean="0"/>
+              <a:rPr lang="en-US"/>
               <a:t>Third level</a:t>
             </a:r>
           </a:p>
           <a:p>
             <a:pPr lvl="3"/>
             <a:r>
-              <a:rPr lang="en-US" smtClean="0"/>
+              <a:rPr lang="en-US"/>
               <a:t>Fourth level</a:t>
             </a:r>
           </a:p>
           <a:p>
             <a:pPr lvl="4"/>
             <a:r>
-              <a:rPr lang="en-US" smtClean="0"/>
+              <a:rPr lang="en-US"/>
               <a:t>Fifth level</a:t>
             </a:r>
-            <a:endParaRPr lang="en-US"/>
           </a:p>
         </p:txBody>
       </p:sp>
@@ -1292,38 +1297,37 @@
           <a:p>
             <a:pPr lvl="0"/>
             <a:r>
-              <a:rPr lang="en-US" smtClean="0"/>
+              <a:rPr lang="en-US"/>
               <a:t>Click to edit Master text styles</a:t>
             </a:r>
           </a:p>
           <a:p>
             <a:pPr lvl="1"/>
             <a:r>
-              <a:rPr lang="en-US" smtClean="0"/>
+              <a:rPr lang="en-US"/>
               <a:t>Second level</a:t>
             </a:r>
           </a:p>
           <a:p>
             <a:pPr lvl="2"/>
             <a:r>
-              <a:rPr lang="en-US" smtClean="0"/>
+              <a:rPr lang="en-US"/>
               <a:t>Third level</a:t>
             </a:r>
           </a:p>
           <a:p>
             <a:pPr lvl="3"/>
             <a:r>
-              <a:rPr lang="en-US" smtClean="0"/>
+              <a:rPr lang="en-US"/>
               <a:t>Fourth level</a:t>
             </a:r>
           </a:p>
           <a:p>
             <a:pPr lvl="4"/>
             <a:r>
-              <a:rPr lang="en-US" smtClean="0"/>
+              <a:rPr lang="en-US"/>
               <a:t>Fifth level</a:t>
             </a:r>
-            <a:endParaRPr lang="en-US"/>
           </a:p>
         </p:txBody>
       </p:sp>
@@ -1344,7 +1348,7 @@
           <a:p>
             <a:fld id="{5BCAD085-E8A6-8845-BD4E-CB4CCA059FC4}" type="datetimeFigureOut">
               <a:rPr lang="en-US" smtClean="0"/>
-              <a:t>1/27/13</a:t>
+              <a:t>10/3/2026</a:t>
             </a:fld>
             <a:endParaRPr lang="en-US"/>
           </a:p>
@@ -1442,10 +1446,9 @@
           </a:lstStyle>
           <a:p>
             <a:r>
-              <a:rPr lang="en-US" smtClean="0"/>
+              <a:rPr lang="en-US"/>
               <a:t>Click to edit Master title style</a:t>
             </a:r>
-            <a:endParaRPr lang="en-US"/>
           </a:p>
         </p:txBody>
       </p:sp>
@@ -1508,7 +1511,7 @@
           <a:p>
             <a:pPr lvl="0"/>
             <a:r>
-              <a:rPr lang="en-US" smtClean="0"/>
+              <a:rPr lang="en-US"/>
               <a:t>Click to edit Master text styles</a:t>
             </a:r>
           </a:p>
@@ -1564,38 +1567,37 @@
           <a:p>
             <a:pPr lvl="0"/>
             <a:r>
-              <a:rPr lang="en-US" smtClean="0"/>
+              <a:rPr lang="en-US"/>
               <a:t>Click to edit Master text styles</a:t>
             </a:r>
           </a:p>
           <a:p>
             <a:pPr lvl="1"/>
             <a:r>
-              <a:rPr lang="en-US" smtClean="0"/>
+              <a:rPr lang="en-US"/>
               <a:t>Second level</a:t>
             </a:r>
           </a:p>
           <a:p>
             <a:pPr lvl="2"/>
             <a:r>
-              <a:rPr lang="en-US" smtClean="0"/>
+              <a:rPr lang="en-US"/>
               <a:t>Third level</a:t>
             </a:r>
           </a:p>
           <a:p>
             <a:pPr lvl="3"/>
             <a:r>
-              <a:rPr lang="en-US" smtClean="0"/>
+              <a:rPr lang="en-US"/>
               <a:t>Fourth level</a:t>
             </a:r>
           </a:p>
           <a:p>
             <a:pPr lvl="4"/>
             <a:r>
-              <a:rPr lang="en-US" smtClean="0"/>
+              <a:rPr lang="en-US"/>
               <a:t>Fifth level</a:t>
             </a:r>
-            <a:endParaRPr lang="en-US"/>
           </a:p>
         </p:txBody>
       </p:sp>
@@ -1658,7 +1660,7 @@
           <a:p>
             <a:pPr lvl="0"/>
             <a:r>
-              <a:rPr lang="en-US" smtClean="0"/>
+              <a:rPr lang="en-US"/>
               <a:t>Click to edit Master text styles</a:t>
             </a:r>
           </a:p>
@@ -1714,38 +1716,37 @@
           <a:p>
             <a:pPr lvl="0"/>
             <a:r>
-              <a:rPr lang="en-US" smtClean="0"/>
+              <a:rPr lang="en-US"/>
               <a:t>Click to edit Master text styles</a:t>
             </a:r>
           </a:p>
           <a:p>
             <a:pPr lvl="1"/>
             <a:r>
-              <a:rPr lang="en-US" smtClean="0"/>
+              <a:rPr lang="en-US"/>
               <a:t>Second level</a:t>
             </a:r>
           </a:p>
           <a:p>
             <a:pPr lvl="2"/>
             <a:r>
-              <a:rPr lang="en-US" smtClean="0"/>
+              <a:rPr lang="en-US"/>
               <a:t>Third level</a:t>
             </a:r>
           </a:p>
           <a:p>
             <a:pPr lvl="3"/>
             <a:r>
-              <a:rPr lang="en-US" smtClean="0"/>
+              <a:rPr lang="en-US"/>
               <a:t>Fourth level</a:t>
             </a:r>
           </a:p>
           <a:p>
             <a:pPr lvl="4"/>
             <a:r>
-              <a:rPr lang="en-US" smtClean="0"/>
+              <a:rPr lang="en-US"/>
               <a:t>Fifth level</a:t>
             </a:r>
-            <a:endParaRPr lang="en-US"/>
           </a:p>
         </p:txBody>
       </p:sp>
@@ -1766,7 +1767,7 @@
           <a:p>
             <a:fld id="{5BCAD085-E8A6-8845-BD4E-CB4CCA059FC4}" type="datetimeFigureOut">
               <a:rPr lang="en-US" smtClean="0"/>
-              <a:t>1/27/13</a:t>
+              <a:t>10/3/2026</a:t>
             </a:fld>
             <a:endParaRPr lang="en-US"/>
           </a:p>
@@ -1860,10 +1861,9 @@
           <a:lstStyle/>
           <a:p>
             <a:r>
-              <a:rPr lang="en-US" smtClean="0"/>
+              <a:rPr lang="en-US"/>
               <a:t>Click to edit Master title style</a:t>
             </a:r>
-            <a:endParaRPr lang="en-US"/>
           </a:p>
         </p:txBody>
       </p:sp>
@@ -1884,7 +1884,7 @@
           <a:p>
             <a:fld id="{5BCAD085-E8A6-8845-BD4E-CB4CCA059FC4}" type="datetimeFigureOut">
               <a:rPr lang="en-US" smtClean="0"/>
-              <a:t>1/27/13</a:t>
+              <a:t>10/3/2026</a:t>
             </a:fld>
             <a:endParaRPr lang="en-US"/>
           </a:p>
@@ -1979,7 +1979,7 @@
           <a:p>
             <a:fld id="{5BCAD085-E8A6-8845-BD4E-CB4CCA059FC4}" type="datetimeFigureOut">
               <a:rPr lang="en-US" smtClean="0"/>
-              <a:t>1/27/13</a:t>
+              <a:t>10/3/2026</a:t>
             </a:fld>
             <a:endParaRPr lang="en-US"/>
           </a:p>
@@ -2082,10 +2082,9 @@
           </a:lstStyle>
           <a:p>
             <a:r>
-              <a:rPr lang="en-US" smtClean="0"/>
+              <a:rPr lang="en-US"/>
               <a:t>Click to edit Master title style</a:t>
             </a:r>
-            <a:endParaRPr lang="en-US"/>
           </a:p>
         </p:txBody>
       </p:sp>
@@ -2139,38 +2138,37 @@
           <a:p>
             <a:pPr lvl="0"/>
             <a:r>
-              <a:rPr lang="en-US" smtClean="0"/>
+              <a:rPr lang="en-US"/>
               <a:t>Click to edit Master text styles</a:t>
             </a:r>
           </a:p>
           <a:p>
             <a:pPr lvl="1"/>
             <a:r>
-              <a:rPr lang="en-US" smtClean="0"/>
+              <a:rPr lang="en-US"/>
               <a:t>Second level</a:t>
             </a:r>
           </a:p>
           <a:p>
             <a:pPr lvl="2"/>
             <a:r>
-              <a:rPr lang="en-US" smtClean="0"/>
+              <a:rPr lang="en-US"/>
               <a:t>Third level</a:t>
             </a:r>
           </a:p>
           <a:p>
             <a:pPr lvl="3"/>
             <a:r>
-              <a:rPr lang="en-US" smtClean="0"/>
+              <a:rPr lang="en-US"/>
               <a:t>Fourth level</a:t>
             </a:r>
           </a:p>
           <a:p>
             <a:pPr lvl="4"/>
             <a:r>
-              <a:rPr lang="en-US" smtClean="0"/>
+              <a:rPr lang="en-US"/>
               <a:t>Fifth level</a:t>
             </a:r>
-            <a:endParaRPr lang="en-US"/>
           </a:p>
         </p:txBody>
       </p:sp>
@@ -2233,7 +2231,7 @@
           <a:p>
             <a:pPr lvl="0"/>
             <a:r>
-              <a:rPr lang="en-US" smtClean="0"/>
+              <a:rPr lang="en-US"/>
               <a:t>Click to edit Master text styles</a:t>
             </a:r>
           </a:p>
@@ -2256,7 +2254,7 @@
           <a:p>
             <a:fld id="{5BCAD085-E8A6-8845-BD4E-CB4CCA059FC4}" type="datetimeFigureOut">
               <a:rPr lang="en-US" smtClean="0"/>
-              <a:t>1/27/13</a:t>
+              <a:t>10/3/2026</a:t>
             </a:fld>
             <a:endParaRPr lang="en-US"/>
           </a:p>
@@ -2359,10 +2357,9 @@
           </a:lstStyle>
           <a:p>
             <a:r>
-              <a:rPr lang="en-US" smtClean="0"/>
+              <a:rPr lang="en-US"/>
               <a:t>Click to edit Master title style</a:t>
             </a:r>
-            <a:endParaRPr lang="en-US"/>
           </a:p>
         </p:txBody>
       </p:sp>
@@ -2486,7 +2483,7 @@
           <a:p>
             <a:pPr lvl="0"/>
             <a:r>
-              <a:rPr lang="en-US" smtClean="0"/>
+              <a:rPr lang="en-US"/>
               <a:t>Click to edit Master text styles</a:t>
             </a:r>
           </a:p>
@@ -2509,7 +2506,7 @@
           <a:p>
             <a:fld id="{5BCAD085-E8A6-8845-BD4E-CB4CCA059FC4}" type="datetimeFigureOut">
               <a:rPr lang="en-US" smtClean="0"/>
-              <a:t>1/27/13</a:t>
+              <a:t>10/3/2026</a:t>
             </a:fld>
             <a:endParaRPr lang="en-US"/>
           </a:p>
@@ -2618,10 +2615,9 @@
           <a:lstStyle/>
           <a:p>
             <a:r>
-              <a:rPr lang="en-US" smtClean="0"/>
+              <a:rPr lang="en-US"/>
               <a:t>Click to edit Master title style</a:t>
             </a:r>
-            <a:endParaRPr lang="en-US"/>
           </a:p>
         </p:txBody>
       </p:sp>
@@ -2652,38 +2648,37 @@
           <a:p>
             <a:pPr lvl="0"/>
             <a:r>
-              <a:rPr lang="en-US" smtClean="0"/>
+              <a:rPr lang="en-US"/>
               <a:t>Click to edit Master text styles</a:t>
             </a:r>
           </a:p>
           <a:p>
             <a:pPr lvl="1"/>
             <a:r>
-              <a:rPr lang="en-US" smtClean="0"/>
+              <a:rPr lang="en-US"/>
               <a:t>Second level</a:t>
             </a:r>
           </a:p>
           <a:p>
             <a:pPr lvl="2"/>
             <a:r>
-              <a:rPr lang="en-US" smtClean="0"/>
+              <a:rPr lang="en-US"/>
               <a:t>Third level</a:t>
             </a:r>
           </a:p>
           <a:p>
             <a:pPr lvl="3"/>
             <a:r>
-              <a:rPr lang="en-US" smtClean="0"/>
+              <a:rPr lang="en-US"/>
               <a:t>Fourth level</a:t>
             </a:r>
           </a:p>
           <a:p>
             <a:pPr lvl="4"/>
             <a:r>
-              <a:rPr lang="en-US" smtClean="0"/>
+              <a:rPr lang="en-US"/>
               <a:t>Fifth level</a:t>
             </a:r>
-            <a:endParaRPr lang="en-US"/>
           </a:p>
         </p:txBody>
       </p:sp>
@@ -2722,7 +2717,7 @@
           <a:p>
             <a:fld id="{5BCAD085-E8A6-8845-BD4E-CB4CCA059FC4}" type="datetimeFigureOut">
               <a:rPr lang="en-US" smtClean="0"/>
-              <a:t>1/27/13</a:t>
+              <a:t>10/3/2026</a:t>
             </a:fld>
             <a:endParaRPr lang="en-US"/>
           </a:p>
@@ -3081,7 +3076,7 @@
 </file>
 
 <file path=ppt/slides/slide1.xml><?xml version="1.0" encoding="utf-8"?>
-<p:sld xmlns:a="http://schemas.openxmlformats.org/drawingml/2006/main" xmlns:p="http://schemas.openxmlformats.org/presentationml/2006/main" xmlns:r="http://schemas.openxmlformats.org/officeDocument/2006/relationships">
+<p:sld xmlns:a="http://schemas.openxmlformats.org/drawingml/2006/main" xmlns:r="http://schemas.openxmlformats.org/officeDocument/2006/relationships" xmlns:p="http://schemas.openxmlformats.org/presentationml/2006/main">
   <p:cSld>
     <p:spTree>
       <p:nvGrpSpPr>
@@ -3089,7 +3084,14 @@
         <p:cNvGrpSpPr/>
         <p:nvPr/>
       </p:nvGrpSpPr>
-      <p:grpSpPr/>
+      <p:grpSpPr>
+        <a:xfrm>
+          <a:off x="0" y="0"/>
+          <a:ext cx="0" cy="0"/>
+          <a:chOff x="0" y="0"/>
+          <a:chExt cx="0" cy="0"/>
+        </a:xfrm>
+      </p:grpSpPr>
       <p:sp>
         <p:nvSpPr>
           <p:cNvPr id="2" name="TextBox 1"/>
@@ -3107,7 +3109,7 @@
           <a:noFill/>
         </p:spPr>
         <p:txBody>
-          <a:bodyPr wrap="square" lIns="0" rIns="0" tIns="0" bIns="0">
+          <a:bodyPr wrap="square" lIns="0" tIns="0" rIns="0" bIns="0">
             <a:spAutoFit/>
           </a:bodyPr>
           <a:lstStyle/>
@@ -3142,7 +3144,7 @@
           <a:noFill/>
         </p:spPr>
         <p:txBody>
-          <a:bodyPr wrap="square" lIns="0" rIns="0" tIns="0" bIns="0">
+          <a:bodyPr wrap="square" lIns="0" tIns="0" rIns="0" bIns="0">
             <a:spAutoFit/>
           </a:bodyPr>
           <a:lstStyle/>
@@ -3169,7 +3171,7 @@
         <p:spPr>
           <a:xfrm>
             <a:off x="384048" y="896112"/>
-            <a:ext cx="11430000" cy="237744"/>
+            <a:ext cx="11430000" cy="169277"/>
           </a:xfrm>
           <a:prstGeom prst="rect">
             <a:avLst/>
@@ -3177,20 +3179,47 @@
           <a:noFill/>
         </p:spPr>
         <p:txBody>
-          <a:bodyPr wrap="square" lIns="0" rIns="0" tIns="0" bIns="0">
+          <a:bodyPr wrap="square" lIns="0" tIns="0" rIns="0" bIns="0">
             <a:spAutoFit/>
           </a:bodyPr>
           <a:lstStyle/>
           <a:p>
             <a:pPr algn="l"/>
             <a:r>
-              <a:rPr sz="1100" b="0" i="0">
+              <a:rPr lang="en-PH" sz="1100" dirty="0">
                 <a:solidFill>
                   <a:srgbClr val="555555"/>
                 </a:solidFill>
                 <a:latin typeface="Calibri"/>
               </a:rPr>
-              <a:t>2 October 2026 · J. Lagana + AI231 ME2 group · Model · Dataset · Training on A100 · Validation on RPi 4</a:t>
+              <a:t>3</a:t>
+            </a:r>
+            <a:r>
+              <a:rPr sz="1100" b="0" i="0" dirty="0">
+                <a:solidFill>
+                  <a:srgbClr val="555555"/>
+                </a:solidFill>
+                <a:latin typeface="Calibri"/>
+              </a:rPr>
+              <a:t> October 2026 · J</a:t>
+            </a:r>
+            <a:r>
+              <a:rPr lang="en-PH" sz="1100" b="0" i="0" dirty="0">
+                <a:solidFill>
+                  <a:srgbClr val="555555"/>
+                </a:solidFill>
+                <a:latin typeface="Calibri"/>
+              </a:rPr>
+              <a:t>an Rhey</a:t>
+            </a:r>
+            <a:r>
+              <a:rPr sz="1100" b="0" i="0" dirty="0">
+                <a:solidFill>
+                  <a:srgbClr val="555555"/>
+                </a:solidFill>
+                <a:latin typeface="Calibri"/>
+              </a:rPr>
+              <a:t> Lagana + AI231 ME2 · Model · Dataset · Training on A100 · Validation on RPi 4</a:t>
             </a:r>
           </a:p>
         </p:txBody>
@@ -3212,7 +3241,7 @@
           <a:noFill/>
         </p:spPr>
         <p:txBody>
-          <a:bodyPr wrap="square" lIns="0" rIns="0" tIns="0" bIns="0">
+          <a:bodyPr wrap="square" lIns="0" tIns="0" rIns="0" bIns="0">
             <a:spAutoFit/>
           </a:bodyPr>
           <a:lstStyle/>
@@ -3269,7 +3298,7 @@
           </a:fontRef>
         </p:style>
         <p:txBody>
-          <a:bodyPr rtlCol="0" anchor="ctr" wrap="square" lIns="82296" rIns="54864" tIns="18288" bIns="18288"/>
+          <a:bodyPr wrap="square" lIns="82296" tIns="18288" rIns="54864" bIns="18288" rtlCol="0" anchor="ctr"/>
           <a:lstStyle/>
           <a:p>
             <a:pPr algn="l"/>
@@ -3331,7 +3360,7 @@
           </a:fontRef>
         </p:style>
         <p:txBody>
-          <a:bodyPr rtlCol="0" anchor="ctr" wrap="square" lIns="82296" rIns="54864" tIns="18288" bIns="18288"/>
+          <a:bodyPr wrap="square" lIns="82296" tIns="18288" rIns="54864" bIns="18288" rtlCol="0" anchor="ctr"/>
           <a:lstStyle/>
           <a:p>
             <a:pPr algn="l"/>
@@ -3393,12 +3422,12 @@
           </a:fontRef>
         </p:style>
         <p:txBody>
-          <a:bodyPr rtlCol="0" anchor="ctr" wrap="square" lIns="82296" rIns="54864" tIns="18288" bIns="18288"/>
+          <a:bodyPr wrap="square" lIns="82296" tIns="18288" rIns="54864" bIns="18288" rtlCol="0" anchor="ctr"/>
           <a:lstStyle/>
           <a:p>
             <a:pPr algn="l"/>
             <a:r>
-              <a:rPr sz="1000" b="1">
+              <a:rPr sz="1000" b="1" dirty="0">
                 <a:solidFill>
                   <a:srgbClr val="C88A2E"/>
                 </a:solidFill>
@@ -3406,12 +3435,44 @@
               <a:t>Intent head  </a:t>
             </a:r>
             <a:r>
-              <a:rPr sz="1000">
+              <a:rPr sz="1000" dirty="0">
                 <a:solidFill>
                   <a:srgbClr val="1A1A1A"/>
                 </a:solidFill>
               </a:rPr>
-              <a:t>20 classes  (19 intents + OUT_OF_SCOPE)</a:t>
+              <a:t>20 classes  (19 intents + </a:t>
+            </a:r>
+            <a:r>
+              <a:rPr sz="700" dirty="0">
+                <a:solidFill>
+                  <a:srgbClr val="1A1A1A"/>
+                </a:solidFill>
+              </a:rPr>
+              <a:t>OUT</a:t>
+            </a:r>
+            <a:r>
+              <a:rPr lang="en-PH" sz="700" dirty="0">
+                <a:solidFill>
+                  <a:srgbClr val="1A1A1A"/>
+                </a:solidFill>
+              </a:rPr>
+              <a:t>_</a:t>
+            </a:r>
+            <a:r>
+              <a:rPr sz="700" dirty="0">
+                <a:solidFill>
+                  <a:srgbClr val="1A1A1A"/>
+                </a:solidFill>
+              </a:rPr>
+              <a:t>OF_SCOPE</a:t>
+            </a:r>
+            <a:r>
+              <a:rPr sz="1000" dirty="0">
+                <a:solidFill>
+                  <a:srgbClr val="1A1A1A"/>
+                </a:solidFill>
+              </a:rPr>
+              <a:t>)</a:t>
             </a:r>
           </a:p>
         </p:txBody>
@@ -3455,7 +3516,7 @@
           </a:fontRef>
         </p:style>
         <p:txBody>
-          <a:bodyPr rtlCol="0" anchor="ctr" wrap="square" lIns="82296" rIns="54864" tIns="18288" bIns="18288"/>
+          <a:bodyPr wrap="square" lIns="82296" tIns="18288" rIns="54864" bIns="18288" rtlCol="0" anchor="ctr"/>
           <a:lstStyle/>
           <a:p>
             <a:pPr algn="l"/>
@@ -3517,7 +3578,7 @@
           </a:fontRef>
         </p:style>
         <p:txBody>
-          <a:bodyPr rtlCol="0" anchor="ctr" wrap="square" lIns="82296" rIns="54864" tIns="18288" bIns="18288"/>
+          <a:bodyPr wrap="square" lIns="82296" tIns="18288" rIns="54864" bIns="18288" rtlCol="0" anchor="ctr"/>
           <a:lstStyle/>
           <a:p>
             <a:pPr algn="l"/>
@@ -3579,7 +3640,7 @@
           </a:fontRef>
         </p:style>
         <p:txBody>
-          <a:bodyPr rtlCol="0" anchor="ctr" wrap="square" lIns="82296" rIns="54864" tIns="18288" bIns="18288"/>
+          <a:bodyPr wrap="square" lIns="82296" tIns="18288" rIns="54864" bIns="18288" rtlCol="0" anchor="ctr"/>
           <a:lstStyle/>
           <a:p>
             <a:pPr algn="l"/>
@@ -3612,7 +3673,7 @@
         </p:nvGraphicFramePr>
         <p:xfrm>
           <a:off x="384048" y="2926080"/>
-          <a:ext cx="5532120" cy="548640"/>
+          <a:ext cx="5532120" cy="600456"/>
         </p:xfrm>
         <a:graphic>
           <a:graphicData uri="http://schemas.openxmlformats.org/drawingml/2006/table">
@@ -3621,13 +3682,25 @@
                 <a:tableStyleId>{5C22544A-7EE6-4342-B048-85BDC9FD1C3A}</a:tableStyleId>
               </a:tblPr>
               <a:tblGrid>
-                <a:gridCol w="2286000"/>
-                <a:gridCol w="3246120"/>
+                <a:gridCol w="2286000">
+                  <a:extLst>
+                    <a:ext uri="{9D8B030D-6E8A-4147-A177-3AD203B41FA5}">
+                      <a16:colId xmlns:a16="http://schemas.microsoft.com/office/drawing/2014/main" val="20000"/>
+                    </a:ext>
+                  </a:extLst>
+                </a:gridCol>
+                <a:gridCol w="3246120">
+                  <a:extLst>
+                    <a:ext uri="{9D8B030D-6E8A-4147-A177-3AD203B41FA5}">
+                      <a16:colId xmlns:a16="http://schemas.microsoft.com/office/drawing/2014/main" val="20001"/>
+                    </a:ext>
+                  </a:extLst>
+                </a:gridCol>
               </a:tblGrid>
               <a:tr h="274320">
                 <a:tc>
                   <a:txBody>
-                    <a:bodyPr wrap="square"/>
+                    <a:bodyPr/>
                     <a:lstStyle/>
                     <a:p>
                       <a:pPr algn="l"/>
@@ -3642,7 +3715,7 @@
                       </a:r>
                     </a:p>
                   </a:txBody>
-                  <a:tcPr anchor="ctr" marL="73152" marR="73152" marT="18288" marB="18288">
+                  <a:tcPr marL="73152" marR="73152" marT="18288" marB="18288" anchor="ctr">
                     <a:solidFill>
                       <a:srgbClr val="16233F"/>
                     </a:solidFill>
@@ -3650,7 +3723,7 @@
                 </a:tc>
                 <a:tc>
                   <a:txBody>
-                    <a:bodyPr wrap="square"/>
+                    <a:bodyPr/>
                     <a:lstStyle/>
                     <a:p>
                       <a:pPr algn="l"/>
@@ -3665,17 +3738,22 @@
                       </a:r>
                     </a:p>
                   </a:txBody>
-                  <a:tcPr anchor="ctr" marL="73152" marR="73152" marT="18288" marB="18288">
+                  <a:tcPr marL="73152" marR="73152" marT="18288" marB="18288" anchor="ctr">
                     <a:solidFill>
                       <a:srgbClr val="16233F"/>
                     </a:solidFill>
                   </a:tcPr>
                 </a:tc>
+                <a:extLst>
+                  <a:ext uri="{0D108BD9-81ED-4DB2-BD59-A6C34878D82A}">
+                    <a16:rowId xmlns:a16="http://schemas.microsoft.com/office/drawing/2014/main" val="10000"/>
+                  </a:ext>
+                </a:extLst>
               </a:tr>
               <a:tr h="274320">
                 <a:tc>
                   <a:txBody>
-                    <a:bodyPr wrap="square"/>
+                    <a:bodyPr/>
                     <a:lstStyle/>
                     <a:p>
                       <a:pPr algn="l"/>
@@ -3690,7 +3768,7 @@
                       </a:r>
                     </a:p>
                   </a:txBody>
-                  <a:tcPr anchor="ctr" marL="73152" marR="73152" marT="18288" marB="18288">
+                  <a:tcPr marL="73152" marR="73152" marT="18288" marB="18288" anchor="ctr">
                     <a:solidFill>
                       <a:srgbClr val="FFFFFF"/>
                     </a:solidFill>
@@ -3698,7 +3776,7 @@
                 </a:tc>
                 <a:tc>
                   <a:txBody>
-                    <a:bodyPr wrap="square"/>
+                    <a:bodyPr/>
                     <a:lstStyle/>
                     <a:p>
                       <a:pPr algn="l"/>
@@ -3713,12 +3791,17 @@
                       </a:r>
                     </a:p>
                   </a:txBody>
-                  <a:tcPr anchor="ctr" marL="73152" marR="73152" marT="18288" marB="18288">
+                  <a:tcPr marL="73152" marR="73152" marT="18288" marB="18288" anchor="ctr">
                     <a:solidFill>
                       <a:srgbClr val="FFFFFF"/>
                     </a:solidFill>
                   </a:tcPr>
                 </a:tc>
+                <a:extLst>
+                  <a:ext uri="{0D108BD9-81ED-4DB2-BD59-A6C34878D82A}">
+                    <a16:rowId xmlns:a16="http://schemas.microsoft.com/office/drawing/2014/main" val="10001"/>
+                  </a:ext>
+                </a:extLst>
               </a:tr>
             </a:tbl>
           </a:graphicData>
@@ -3741,7 +3824,7 @@
           <a:noFill/>
         </p:spPr>
         <p:txBody>
-          <a:bodyPr wrap="square" lIns="0" rIns="0" tIns="0" bIns="0">
+          <a:bodyPr wrap="square" lIns="0" tIns="0" rIns="0" bIns="0">
             <a:spAutoFit/>
           </a:bodyPr>
           <a:lstStyle/>
@@ -3778,13 +3861,25 @@
                 <a:tableStyleId>{5C22544A-7EE6-4342-B048-85BDC9FD1C3A}</a:tableStyleId>
               </a:tblPr>
               <a:tblGrid>
-                <a:gridCol w="2286000"/>
-                <a:gridCol w="3246120"/>
+                <a:gridCol w="2286000">
+                  <a:extLst>
+                    <a:ext uri="{9D8B030D-6E8A-4147-A177-3AD203B41FA5}">
+                      <a16:colId xmlns:a16="http://schemas.microsoft.com/office/drawing/2014/main" val="20000"/>
+                    </a:ext>
+                  </a:extLst>
+                </a:gridCol>
+                <a:gridCol w="3246120">
+                  <a:extLst>
+                    <a:ext uri="{9D8B030D-6E8A-4147-A177-3AD203B41FA5}">
+                      <a16:colId xmlns:a16="http://schemas.microsoft.com/office/drawing/2014/main" val="20001"/>
+                    </a:ext>
+                  </a:extLst>
+                </a:gridCol>
               </a:tblGrid>
               <a:tr h="429768">
                 <a:tc>
                   <a:txBody>
-                    <a:bodyPr wrap="square"/>
+                    <a:bodyPr/>
                     <a:lstStyle/>
                     <a:p>
                       <a:pPr algn="l"/>
@@ -3799,7 +3894,7 @@
                       </a:r>
                     </a:p>
                   </a:txBody>
-                  <a:tcPr anchor="ctr" marL="73152" marR="73152" marT="18288" marB="18288">
+                  <a:tcPr marL="73152" marR="73152" marT="18288" marB="18288" anchor="ctr">
                     <a:solidFill>
                       <a:srgbClr val="16233F"/>
                     </a:solidFill>
@@ -3807,7 +3902,7 @@
                 </a:tc>
                 <a:tc>
                   <a:txBody>
-                    <a:bodyPr wrap="square"/>
+                    <a:bodyPr/>
                     <a:lstStyle/>
                     <a:p>
                       <a:pPr algn="l"/>
@@ -3822,17 +3917,22 @@
                       </a:r>
                     </a:p>
                   </a:txBody>
-                  <a:tcPr anchor="ctr" marL="73152" marR="73152" marT="18288" marB="18288">
+                  <a:tcPr marL="73152" marR="73152" marT="18288" marB="18288" anchor="ctr">
                     <a:solidFill>
                       <a:srgbClr val="16233F"/>
                     </a:solidFill>
                   </a:tcPr>
                 </a:tc>
+                <a:extLst>
+                  <a:ext uri="{0D108BD9-81ED-4DB2-BD59-A6C34878D82A}">
+                    <a16:rowId xmlns:a16="http://schemas.microsoft.com/office/drawing/2014/main" val="10000"/>
+                  </a:ext>
+                </a:extLst>
               </a:tr>
               <a:tr h="429768">
                 <a:tc>
                   <a:txBody>
-                    <a:bodyPr wrap="square"/>
+                    <a:bodyPr/>
                     <a:lstStyle/>
                     <a:p>
                       <a:pPr algn="l"/>
@@ -3847,7 +3947,7 @@
                       </a:r>
                     </a:p>
                   </a:txBody>
-                  <a:tcPr anchor="ctr" marL="73152" marR="73152" marT="18288" marB="18288">
+                  <a:tcPr marL="73152" marR="73152" marT="18288" marB="18288" anchor="ctr">
                     <a:solidFill>
                       <a:srgbClr val="FFFFFF"/>
                     </a:solidFill>
@@ -3855,7 +3955,7 @@
                 </a:tc>
                 <a:tc>
                   <a:txBody>
-                    <a:bodyPr wrap="square"/>
+                    <a:bodyPr/>
                     <a:lstStyle/>
                     <a:p>
                       <a:pPr algn="l"/>
@@ -3870,17 +3970,22 @@
                       </a:r>
                     </a:p>
                   </a:txBody>
-                  <a:tcPr anchor="ctr" marL="73152" marR="73152" marT="18288" marB="18288">
+                  <a:tcPr marL="73152" marR="73152" marT="18288" marB="18288" anchor="ctr">
                     <a:solidFill>
                       <a:srgbClr val="FFFFFF"/>
                     </a:solidFill>
                   </a:tcPr>
                 </a:tc>
+                <a:extLst>
+                  <a:ext uri="{0D108BD9-81ED-4DB2-BD59-A6C34878D82A}">
+                    <a16:rowId xmlns:a16="http://schemas.microsoft.com/office/drawing/2014/main" val="10001"/>
+                  </a:ext>
+                </a:extLst>
               </a:tr>
               <a:tr h="429768">
                 <a:tc>
                   <a:txBody>
-                    <a:bodyPr wrap="square"/>
+                    <a:bodyPr/>
                     <a:lstStyle/>
                     <a:p>
                       <a:pPr algn="l"/>
@@ -3895,7 +4000,7 @@
                       </a:r>
                     </a:p>
                   </a:txBody>
-                  <a:tcPr anchor="ctr" marL="73152" marR="73152" marT="18288" marB="18288">
+                  <a:tcPr marL="73152" marR="73152" marT="18288" marB="18288" anchor="ctr">
                     <a:solidFill>
                       <a:srgbClr val="F2F6FB"/>
                     </a:solidFill>
@@ -3903,7 +4008,7 @@
                 </a:tc>
                 <a:tc>
                   <a:txBody>
-                    <a:bodyPr wrap="square"/>
+                    <a:bodyPr/>
                     <a:lstStyle/>
                     <a:p>
                       <a:pPr algn="l"/>
@@ -3918,17 +4023,22 @@
                       </a:r>
                     </a:p>
                   </a:txBody>
-                  <a:tcPr anchor="ctr" marL="73152" marR="73152" marT="18288" marB="18288">
+                  <a:tcPr marL="73152" marR="73152" marT="18288" marB="18288" anchor="ctr">
                     <a:solidFill>
                       <a:srgbClr val="F2F6FB"/>
                     </a:solidFill>
                   </a:tcPr>
                 </a:tc>
+                <a:extLst>
+                  <a:ext uri="{0D108BD9-81ED-4DB2-BD59-A6C34878D82A}">
+                    <a16:rowId xmlns:a16="http://schemas.microsoft.com/office/drawing/2014/main" val="10002"/>
+                  </a:ext>
+                </a:extLst>
               </a:tr>
               <a:tr h="429768">
                 <a:tc>
                   <a:txBody>
-                    <a:bodyPr wrap="square"/>
+                    <a:bodyPr/>
                     <a:lstStyle/>
                     <a:p>
                       <a:pPr algn="l"/>
@@ -3943,7 +4053,7 @@
                       </a:r>
                     </a:p>
                   </a:txBody>
-                  <a:tcPr anchor="ctr" marL="73152" marR="73152" marT="18288" marB="18288">
+                  <a:tcPr marL="73152" marR="73152" marT="18288" marB="18288" anchor="ctr">
                     <a:solidFill>
                       <a:srgbClr val="FFFFFF"/>
                     </a:solidFill>
@@ -3951,7 +4061,7 @@
                 </a:tc>
                 <a:tc>
                   <a:txBody>
-                    <a:bodyPr wrap="square"/>
+                    <a:bodyPr/>
                     <a:lstStyle/>
                     <a:p>
                       <a:pPr algn="l"/>
@@ -3966,17 +4076,22 @@
                       </a:r>
                     </a:p>
                   </a:txBody>
-                  <a:tcPr anchor="ctr" marL="73152" marR="73152" marT="18288" marB="18288">
+                  <a:tcPr marL="73152" marR="73152" marT="18288" marB="18288" anchor="ctr">
                     <a:solidFill>
                       <a:srgbClr val="FFFFFF"/>
                     </a:solidFill>
                   </a:tcPr>
                 </a:tc>
+                <a:extLst>
+                  <a:ext uri="{0D108BD9-81ED-4DB2-BD59-A6C34878D82A}">
+                    <a16:rowId xmlns:a16="http://schemas.microsoft.com/office/drawing/2014/main" val="10003"/>
+                  </a:ext>
+                </a:extLst>
               </a:tr>
               <a:tr h="429768">
                 <a:tc>
                   <a:txBody>
-                    <a:bodyPr wrap="square"/>
+                    <a:bodyPr/>
                     <a:lstStyle/>
                     <a:p>
                       <a:pPr algn="l"/>
@@ -3991,7 +4106,7 @@
                       </a:r>
                     </a:p>
                   </a:txBody>
-                  <a:tcPr anchor="ctr" marL="73152" marR="73152" marT="18288" marB="18288">
+                  <a:tcPr marL="73152" marR="73152" marT="18288" marB="18288" anchor="ctr">
                     <a:solidFill>
                       <a:srgbClr val="F2F6FB"/>
                     </a:solidFill>
@@ -3999,7 +4114,7 @@
                 </a:tc>
                 <a:tc>
                   <a:txBody>
-                    <a:bodyPr wrap="square"/>
+                    <a:bodyPr/>
                     <a:lstStyle/>
                     <a:p>
                       <a:pPr algn="l"/>
@@ -4014,12 +4129,17 @@
                       </a:r>
                     </a:p>
                   </a:txBody>
-                  <a:tcPr anchor="ctr" marL="73152" marR="73152" marT="18288" marB="18288">
+                  <a:tcPr marL="73152" marR="73152" marT="18288" marB="18288" anchor="ctr">
                     <a:solidFill>
                       <a:srgbClr val="F2F6FB"/>
                     </a:solidFill>
                   </a:tcPr>
                 </a:tc>
+                <a:extLst>
+                  <a:ext uri="{0D108BD9-81ED-4DB2-BD59-A6C34878D82A}">
+                    <a16:rowId xmlns:a16="http://schemas.microsoft.com/office/drawing/2014/main" val="10004"/>
+                  </a:ext>
+                </a:extLst>
               </a:tr>
             </a:tbl>
           </a:graphicData>
@@ -4042,7 +4162,7 @@
           <a:noFill/>
         </p:spPr>
         <p:txBody>
-          <a:bodyPr wrap="square" lIns="0" rIns="0" tIns="0" bIns="0">
+          <a:bodyPr wrap="square" lIns="0" tIns="0" rIns="0" bIns="0">
             <a:spAutoFit/>
           </a:bodyPr>
           <a:lstStyle/>
@@ -4079,13 +4199,25 @@
                 <a:tableStyleId>{5C22544A-7EE6-4342-B048-85BDC9FD1C3A}</a:tableStyleId>
               </a:tblPr>
               <a:tblGrid>
-                <a:gridCol w="1737360"/>
-                <a:gridCol w="3794760"/>
+                <a:gridCol w="1737360">
+                  <a:extLst>
+                    <a:ext uri="{9D8B030D-6E8A-4147-A177-3AD203B41FA5}">
+                      <a16:colId xmlns:a16="http://schemas.microsoft.com/office/drawing/2014/main" val="20000"/>
+                    </a:ext>
+                  </a:extLst>
+                </a:gridCol>
+                <a:gridCol w="3794760">
+                  <a:extLst>
+                    <a:ext uri="{9D8B030D-6E8A-4147-A177-3AD203B41FA5}">
+                      <a16:colId xmlns:a16="http://schemas.microsoft.com/office/drawing/2014/main" val="20001"/>
+                    </a:ext>
+                  </a:extLst>
+                </a:gridCol>
               </a:tblGrid>
               <a:tr h="502920">
                 <a:tc>
                   <a:txBody>
-                    <a:bodyPr wrap="square"/>
+                    <a:bodyPr/>
                     <a:lstStyle/>
                     <a:p>
                       <a:pPr algn="l"/>
@@ -4100,7 +4232,7 @@
                       </a:r>
                     </a:p>
                   </a:txBody>
-                  <a:tcPr anchor="ctr" marL="73152" marR="73152" marT="18288" marB="18288">
+                  <a:tcPr marL="73152" marR="73152" marT="18288" marB="18288" anchor="ctr">
                     <a:solidFill>
                       <a:srgbClr val="16233F"/>
                     </a:solidFill>
@@ -4108,7 +4240,7 @@
                 </a:tc>
                 <a:tc>
                   <a:txBody>
-                    <a:bodyPr wrap="square"/>
+                    <a:bodyPr/>
                     <a:lstStyle/>
                     <a:p>
                       <a:pPr algn="l"/>
@@ -4123,17 +4255,22 @@
                       </a:r>
                     </a:p>
                   </a:txBody>
-                  <a:tcPr anchor="ctr" marL="73152" marR="73152" marT="18288" marB="18288">
+                  <a:tcPr marL="73152" marR="73152" marT="18288" marB="18288" anchor="ctr">
                     <a:solidFill>
                       <a:srgbClr val="16233F"/>
                     </a:solidFill>
                   </a:tcPr>
                 </a:tc>
+                <a:extLst>
+                  <a:ext uri="{0D108BD9-81ED-4DB2-BD59-A6C34878D82A}">
+                    <a16:rowId xmlns:a16="http://schemas.microsoft.com/office/drawing/2014/main" val="10000"/>
+                  </a:ext>
+                </a:extLst>
               </a:tr>
               <a:tr h="502920">
                 <a:tc>
                   <a:txBody>
-                    <a:bodyPr wrap="square"/>
+                    <a:bodyPr/>
                     <a:lstStyle/>
                     <a:p>
                       <a:pPr algn="l"/>
@@ -4148,7 +4285,7 @@
                       </a:r>
                     </a:p>
                   </a:txBody>
-                  <a:tcPr anchor="ctr" marL="73152" marR="73152" marT="18288" marB="18288">
+                  <a:tcPr marL="73152" marR="73152" marT="18288" marB="18288" anchor="ctr">
                     <a:solidFill>
                       <a:srgbClr val="FFFFFF"/>
                     </a:solidFill>
@@ -4156,7 +4293,7 @@
                 </a:tc>
                 <a:tc>
                   <a:txBody>
-                    <a:bodyPr wrap="square"/>
+                    <a:bodyPr/>
                     <a:lstStyle/>
                     <a:p>
                       <a:pPr algn="l"/>
@@ -4171,32 +4308,52 @@
                       </a:r>
                     </a:p>
                   </a:txBody>
-                  <a:tcPr anchor="ctr" marL="73152" marR="73152" marT="18288" marB="18288">
+                  <a:tcPr marL="73152" marR="73152" marT="18288" marB="18288" anchor="ctr">
                     <a:solidFill>
                       <a:srgbClr val="FFFFFF"/>
                     </a:solidFill>
                   </a:tcPr>
                 </a:tc>
+                <a:extLst>
+                  <a:ext uri="{0D108BD9-81ED-4DB2-BD59-A6C34878D82A}">
+                    <a16:rowId xmlns:a16="http://schemas.microsoft.com/office/drawing/2014/main" val="10001"/>
+                  </a:ext>
+                </a:extLst>
               </a:tr>
               <a:tr h="502920">
                 <a:tc>
                   <a:txBody>
-                    <a:bodyPr wrap="square"/>
+                    <a:bodyPr/>
                     <a:lstStyle/>
                     <a:p>
                       <a:pPr algn="l"/>
                       <a:r>
-                        <a:rPr sz="950" b="1">
+                        <a:rPr sz="950" b="1" dirty="0">
                           <a:solidFill>
                             <a:srgbClr val="1A1A1A"/>
                           </a:solidFill>
                           <a:latin typeface="Calibri"/>
                         </a:rPr>
-                        <a:t>Hours / utts</a:t>
+                        <a:t>Hours / </a:t>
                       </a:r>
+                      <a:r>
+                        <a:rPr sz="950" b="1" dirty="0" err="1">
+                          <a:solidFill>
+                            <a:srgbClr val="1A1A1A"/>
+                          </a:solidFill>
+                          <a:latin typeface="Calibri"/>
+                        </a:rPr>
+                        <a:t>utts</a:t>
+                      </a:r>
+                      <a:endParaRPr sz="950" b="1" dirty="0">
+                        <a:solidFill>
+                          <a:srgbClr val="1A1A1A"/>
+                        </a:solidFill>
+                        <a:latin typeface="Calibri"/>
+                      </a:endParaRPr>
                     </a:p>
                   </a:txBody>
-                  <a:tcPr anchor="ctr" marL="73152" marR="73152" marT="18288" marB="18288">
+                  <a:tcPr marL="73152" marR="73152" marT="18288" marB="18288" anchor="ctr">
                     <a:solidFill>
                       <a:srgbClr val="F2F6FB"/>
                     </a:solidFill>
@@ -4204,32 +4361,37 @@
                 </a:tc>
                 <a:tc>
                   <a:txBody>
-                    <a:bodyPr wrap="square"/>
+                    <a:bodyPr/>
                     <a:lstStyle/>
                     <a:p>
                       <a:pPr algn="l"/>
                       <a:r>
                         <a:rPr sz="950" b="0">
                           <a:solidFill>
-                            <a:srgbClr val="B86A00"/>
+                            <a:srgbClr val="1A1A1A"/>
                           </a:solidFill>
                           <a:latin typeface="Calibri"/>
                         </a:rPr>
-                        <a:t>81,768 clips · train 10,733 / test 4,443 / holdout 202 · ≈25–30 h audio (est.)</a:t>
+                        <a:t>15,378 command clips (train 10,733 / test 4,443 / holdout 202); + 66,390-clip number-robustness bench</a:t>
                       </a:r>
                     </a:p>
                   </a:txBody>
-                  <a:tcPr anchor="ctr" marL="73152" marR="73152" marT="18288" marB="18288">
+                  <a:tcPr marL="73152" marR="73152" marT="18288" marB="18288" anchor="ctr">
                     <a:solidFill>
                       <a:srgbClr val="F2F6FB"/>
                     </a:solidFill>
                   </a:tcPr>
                 </a:tc>
+                <a:extLst>
+                  <a:ext uri="{0D108BD9-81ED-4DB2-BD59-A6C34878D82A}">
+                    <a16:rowId xmlns:a16="http://schemas.microsoft.com/office/drawing/2014/main" val="10002"/>
+                  </a:ext>
+                </a:extLst>
               </a:tr>
               <a:tr h="502920">
                 <a:tc>
                   <a:txBody>
-                    <a:bodyPr wrap="square"/>
+                    <a:bodyPr/>
                     <a:lstStyle/>
                     <a:p>
                       <a:pPr algn="l"/>
@@ -4244,7 +4406,7 @@
                       </a:r>
                     </a:p>
                   </a:txBody>
-                  <a:tcPr anchor="ctr" marL="73152" marR="73152" marT="18288" marB="18288">
+                  <a:tcPr marL="73152" marR="73152" marT="18288" marB="18288" anchor="ctr">
                     <a:solidFill>
                       <a:srgbClr val="FFFFFF"/>
                     </a:solidFill>
@@ -4252,7 +4414,7 @@
                 </a:tc>
                 <a:tc>
                   <a:txBody>
-                    <a:bodyPr wrap="square"/>
+                    <a:bodyPr/>
                     <a:lstStyle/>
                     <a:p>
                       <a:pPr algn="l"/>
@@ -4267,17 +4429,22 @@
                       </a:r>
                     </a:p>
                   </a:txBody>
-                  <a:tcPr anchor="ctr" marL="73152" marR="73152" marT="18288" marB="18288">
+                  <a:tcPr marL="73152" marR="73152" marT="18288" marB="18288" anchor="ctr">
                     <a:solidFill>
                       <a:srgbClr val="FFFFFF"/>
                     </a:solidFill>
                   </a:tcPr>
                 </a:tc>
+                <a:extLst>
+                  <a:ext uri="{0D108BD9-81ED-4DB2-BD59-A6C34878D82A}">
+                    <a16:rowId xmlns:a16="http://schemas.microsoft.com/office/drawing/2014/main" val="10003"/>
+                  </a:ext>
+                </a:extLst>
               </a:tr>
               <a:tr h="502920">
                 <a:tc>
                   <a:txBody>
-                    <a:bodyPr wrap="square"/>
+                    <a:bodyPr/>
                     <a:lstStyle/>
                     <a:p>
                       <a:pPr algn="l"/>
@@ -4292,7 +4459,7 @@
                       </a:r>
                     </a:p>
                   </a:txBody>
-                  <a:tcPr anchor="ctr" marL="73152" marR="73152" marT="18288" marB="18288">
+                  <a:tcPr marL="73152" marR="73152" marT="18288" marB="18288" anchor="ctr">
                     <a:solidFill>
                       <a:srgbClr val="F2F6FB"/>
                     </a:solidFill>
@@ -4300,12 +4467,12 @@
                 </a:tc>
                 <a:tc>
                   <a:txBody>
-                    <a:bodyPr wrap="square"/>
+                    <a:bodyPr/>
                     <a:lstStyle/>
                     <a:p>
                       <a:pPr algn="l"/>
                       <a:r>
-                        <a:rPr sz="950" b="0">
+                        <a:rPr sz="950" b="0" dirty="0">
                           <a:solidFill>
                             <a:srgbClr val="1A1A1A"/>
                           </a:solidFill>
@@ -4315,12 +4482,17 @@
                       </a:r>
                     </a:p>
                   </a:txBody>
-                  <a:tcPr anchor="ctr" marL="73152" marR="73152" marT="18288" marB="18288">
+                  <a:tcPr marL="73152" marR="73152" marT="18288" marB="18288" anchor="ctr">
                     <a:solidFill>
                       <a:srgbClr val="F2F6FB"/>
                     </a:solidFill>
                   </a:tcPr>
                 </a:tc>
+                <a:extLst>
+                  <a:ext uri="{0D108BD9-81ED-4DB2-BD59-A6C34878D82A}">
+                    <a16:rowId xmlns:a16="http://schemas.microsoft.com/office/drawing/2014/main" val="10004"/>
+                  </a:ext>
+                </a:extLst>
               </a:tr>
             </a:tbl>
           </a:graphicData>
@@ -4343,7 +4515,7 @@
           <a:noFill/>
         </p:spPr>
         <p:txBody>
-          <a:bodyPr wrap="square" lIns="0" rIns="0" tIns="0" bIns="0">
+          <a:bodyPr wrap="square" lIns="0" tIns="0" rIns="0" bIns="0">
             <a:spAutoFit/>
           </a:bodyPr>
           <a:lstStyle/>
@@ -4380,13 +4552,25 @@
                 <a:tableStyleId>{5C22544A-7EE6-4342-B048-85BDC9FD1C3A}</a:tableStyleId>
               </a:tblPr>
               <a:tblGrid>
-                <a:gridCol w="1737360"/>
-                <a:gridCol w="3794760"/>
+                <a:gridCol w="1737360">
+                  <a:extLst>
+                    <a:ext uri="{9D8B030D-6E8A-4147-A177-3AD203B41FA5}">
+                      <a16:colId xmlns:a16="http://schemas.microsoft.com/office/drawing/2014/main" val="20000"/>
+                    </a:ext>
+                  </a:extLst>
+                </a:gridCol>
+                <a:gridCol w="3794760">
+                  <a:extLst>
+                    <a:ext uri="{9D8B030D-6E8A-4147-A177-3AD203B41FA5}">
+                      <a16:colId xmlns:a16="http://schemas.microsoft.com/office/drawing/2014/main" val="20001"/>
+                    </a:ext>
+                  </a:extLst>
+                </a:gridCol>
               </a:tblGrid>
               <a:tr h="384048">
                 <a:tc>
                   <a:txBody>
-                    <a:bodyPr wrap="square"/>
+                    <a:bodyPr/>
                     <a:lstStyle/>
                     <a:p>
                       <a:pPr algn="l"/>
@@ -4401,7 +4585,7 @@
                       </a:r>
                     </a:p>
                   </a:txBody>
-                  <a:tcPr anchor="ctr" marL="73152" marR="73152" marT="18288" marB="18288">
+                  <a:tcPr marL="73152" marR="73152" marT="18288" marB="18288" anchor="ctr">
                     <a:solidFill>
                       <a:srgbClr val="16233F"/>
                     </a:solidFill>
@@ -4409,7 +4593,7 @@
                 </a:tc>
                 <a:tc>
                   <a:txBody>
-                    <a:bodyPr wrap="square"/>
+                    <a:bodyPr/>
                     <a:lstStyle/>
                     <a:p>
                       <a:pPr algn="l"/>
@@ -4424,17 +4608,22 @@
                       </a:r>
                     </a:p>
                   </a:txBody>
-                  <a:tcPr anchor="ctr" marL="73152" marR="73152" marT="18288" marB="18288">
+                  <a:tcPr marL="73152" marR="73152" marT="18288" marB="18288" anchor="ctr">
                     <a:solidFill>
                       <a:srgbClr val="16233F"/>
                     </a:solidFill>
                   </a:tcPr>
                 </a:tc>
+                <a:extLst>
+                  <a:ext uri="{0D108BD9-81ED-4DB2-BD59-A6C34878D82A}">
+                    <a16:rowId xmlns:a16="http://schemas.microsoft.com/office/drawing/2014/main" val="10000"/>
+                  </a:ext>
+                </a:extLst>
               </a:tr>
               <a:tr h="384048">
                 <a:tc>
                   <a:txBody>
-                    <a:bodyPr wrap="square"/>
+                    <a:bodyPr/>
                     <a:lstStyle/>
                     <a:p>
                       <a:pPr algn="l"/>
@@ -4449,7 +4638,7 @@
                       </a:r>
                     </a:p>
                   </a:txBody>
-                  <a:tcPr anchor="ctr" marL="73152" marR="73152" marT="18288" marB="18288">
+                  <a:tcPr marL="73152" marR="73152" marT="18288" marB="18288" anchor="ctr">
                     <a:solidFill>
                       <a:srgbClr val="FFFFFF"/>
                     </a:solidFill>
@@ -4457,7 +4646,7 @@
                 </a:tc>
                 <a:tc>
                   <a:txBody>
-                    <a:bodyPr wrap="square"/>
+                    <a:bodyPr/>
                     <a:lstStyle/>
                     <a:p>
                       <a:pPr algn="l"/>
@@ -4472,17 +4661,22 @@
                       </a:r>
                     </a:p>
                   </a:txBody>
-                  <a:tcPr anchor="ctr" marL="73152" marR="73152" marT="18288" marB="18288">
+                  <a:tcPr marL="73152" marR="73152" marT="18288" marB="18288" anchor="ctr">
                     <a:solidFill>
                       <a:srgbClr val="FFFFFF"/>
                     </a:solidFill>
                   </a:tcPr>
                 </a:tc>
+                <a:extLst>
+                  <a:ext uri="{0D108BD9-81ED-4DB2-BD59-A6C34878D82A}">
+                    <a16:rowId xmlns:a16="http://schemas.microsoft.com/office/drawing/2014/main" val="10001"/>
+                  </a:ext>
+                </a:extLst>
               </a:tr>
               <a:tr h="384048">
                 <a:tc>
                   <a:txBody>
-                    <a:bodyPr wrap="square"/>
+                    <a:bodyPr/>
                     <a:lstStyle/>
                     <a:p>
                       <a:pPr algn="l"/>
@@ -4497,7 +4691,7 @@
                       </a:r>
                     </a:p>
                   </a:txBody>
-                  <a:tcPr anchor="ctr" marL="73152" marR="73152" marT="18288" marB="18288">
+                  <a:tcPr marL="73152" marR="73152" marT="18288" marB="18288" anchor="ctr">
                     <a:solidFill>
                       <a:srgbClr val="F2F6FB"/>
                     </a:solidFill>
@@ -4505,7 +4699,7 @@
                 </a:tc>
                 <a:tc>
                   <a:txBody>
-                    <a:bodyPr wrap="square"/>
+                    <a:bodyPr/>
                     <a:lstStyle/>
                     <a:p>
                       <a:pPr algn="l"/>
@@ -4520,17 +4714,22 @@
                       </a:r>
                     </a:p>
                   </a:txBody>
-                  <a:tcPr anchor="ctr" marL="73152" marR="73152" marT="18288" marB="18288">
+                  <a:tcPr marL="73152" marR="73152" marT="18288" marB="18288" anchor="ctr">
                     <a:solidFill>
                       <a:srgbClr val="F2F6FB"/>
                     </a:solidFill>
                   </a:tcPr>
                 </a:tc>
+                <a:extLst>
+                  <a:ext uri="{0D108BD9-81ED-4DB2-BD59-A6C34878D82A}">
+                    <a16:rowId xmlns:a16="http://schemas.microsoft.com/office/drawing/2014/main" val="10002"/>
+                  </a:ext>
+                </a:extLst>
               </a:tr>
               <a:tr h="384048">
                 <a:tc>
                   <a:txBody>
-                    <a:bodyPr wrap="square"/>
+                    <a:bodyPr/>
                     <a:lstStyle/>
                     <a:p>
                       <a:pPr algn="l"/>
@@ -4545,7 +4744,7 @@
                       </a:r>
                     </a:p>
                   </a:txBody>
-                  <a:tcPr anchor="ctr" marL="73152" marR="73152" marT="18288" marB="18288">
+                  <a:tcPr marL="73152" marR="73152" marT="18288" marB="18288" anchor="ctr">
                     <a:solidFill>
                       <a:srgbClr val="FFFFFF"/>
                     </a:solidFill>
@@ -4553,7 +4752,7 @@
                 </a:tc>
                 <a:tc>
                   <a:txBody>
-                    <a:bodyPr wrap="square"/>
+                    <a:bodyPr/>
                     <a:lstStyle/>
                     <a:p>
                       <a:pPr algn="l"/>
@@ -4568,17 +4767,22 @@
                       </a:r>
                     </a:p>
                   </a:txBody>
-                  <a:tcPr anchor="ctr" marL="73152" marR="73152" marT="18288" marB="18288">
+                  <a:tcPr marL="73152" marR="73152" marT="18288" marB="18288" anchor="ctr">
                     <a:solidFill>
                       <a:srgbClr val="FFFFFF"/>
                     </a:solidFill>
                   </a:tcPr>
                 </a:tc>
+                <a:extLst>
+                  <a:ext uri="{0D108BD9-81ED-4DB2-BD59-A6C34878D82A}">
+                    <a16:rowId xmlns:a16="http://schemas.microsoft.com/office/drawing/2014/main" val="10003"/>
+                  </a:ext>
+                </a:extLst>
               </a:tr>
               <a:tr h="384048">
                 <a:tc>
                   <a:txBody>
-                    <a:bodyPr wrap="square"/>
+                    <a:bodyPr/>
                     <a:lstStyle/>
                     <a:p>
                       <a:pPr algn="l"/>
@@ -4593,7 +4797,7 @@
                       </a:r>
                     </a:p>
                   </a:txBody>
-                  <a:tcPr anchor="ctr" marL="73152" marR="73152" marT="18288" marB="18288">
+                  <a:tcPr marL="73152" marR="73152" marT="18288" marB="18288" anchor="ctr">
                     <a:solidFill>
                       <a:srgbClr val="F2F6FB"/>
                     </a:solidFill>
@@ -4601,7 +4805,7 @@
                 </a:tc>
                 <a:tc>
                   <a:txBody>
-                    <a:bodyPr wrap="square"/>
+                    <a:bodyPr/>
                     <a:lstStyle/>
                     <a:p>
                       <a:pPr algn="l"/>
@@ -4616,12 +4820,17 @@
                       </a:r>
                     </a:p>
                   </a:txBody>
-                  <a:tcPr anchor="ctr" marL="73152" marR="73152" marT="18288" marB="18288">
+                  <a:tcPr marL="73152" marR="73152" marT="18288" marB="18288" anchor="ctr">
                     <a:solidFill>
                       <a:srgbClr val="F2F6FB"/>
                     </a:solidFill>
                   </a:tcPr>
                 </a:tc>
+                <a:extLst>
+                  <a:ext uri="{0D108BD9-81ED-4DB2-BD59-A6C34878D82A}">
+                    <a16:rowId xmlns:a16="http://schemas.microsoft.com/office/drawing/2014/main" val="10004"/>
+                  </a:ext>
+                </a:extLst>
               </a:tr>
             </a:tbl>
           </a:graphicData>
@@ -4644,7 +4853,7 @@
           <a:noFill/>
         </p:spPr>
         <p:txBody>
-          <a:bodyPr wrap="square" lIns="0" rIns="0" tIns="0" bIns="0">
+          <a:bodyPr wrap="square" lIns="0" tIns="0" rIns="0" bIns="0">
             <a:spAutoFit/>
           </a:bodyPr>
           <a:lstStyle/>
@@ -4671,7 +4880,7 @@
 </file>
 
 <file path=ppt/slides/slide2.xml><?xml version="1.0" encoding="utf-8"?>
-<p:sld xmlns:a="http://schemas.openxmlformats.org/drawingml/2006/main" xmlns:p="http://schemas.openxmlformats.org/presentationml/2006/main" xmlns:r="http://schemas.openxmlformats.org/officeDocument/2006/relationships">
+<p:sld xmlns:a="http://schemas.openxmlformats.org/drawingml/2006/main" xmlns:r="http://schemas.openxmlformats.org/officeDocument/2006/relationships" xmlns:p="http://schemas.openxmlformats.org/presentationml/2006/main">
   <p:cSld>
     <p:spTree>
       <p:nvGrpSpPr>
@@ -4679,7 +4888,14 @@
         <p:cNvGrpSpPr/>
         <p:nvPr/>
       </p:nvGrpSpPr>
-      <p:grpSpPr/>
+      <p:grpSpPr>
+        <a:xfrm>
+          <a:off x="0" y="0"/>
+          <a:ext cx="0" cy="0"/>
+          <a:chOff x="0" y="0"/>
+          <a:chExt cx="0" cy="0"/>
+        </a:xfrm>
+      </p:grpSpPr>
       <p:sp>
         <p:nvSpPr>
           <p:cNvPr id="2" name="TextBox 1"/>
@@ -4697,7 +4913,7 @@
           <a:noFill/>
         </p:spPr>
         <p:txBody>
-          <a:bodyPr wrap="square" lIns="0" rIns="0" tIns="0" bIns="0">
+          <a:bodyPr wrap="square" lIns="0" tIns="0" rIns="0" bIns="0">
             <a:spAutoFit/>
           </a:bodyPr>
           <a:lstStyle/>
@@ -4756,6 +4972,7 @@
           <a:lstStyle/>
           <a:p>
             <a:pPr algn="ctr"/>
+            <a:endParaRPr/>
           </a:p>
         </p:txBody>
       </p:sp>
@@ -4778,13 +4995,25 @@
                 <a:tableStyleId>{5C22544A-7EE6-4342-B048-85BDC9FD1C3A}</a:tableStyleId>
               </a:tblPr>
               <a:tblGrid>
-                <a:gridCol w="3108960"/>
-                <a:gridCol w="8321040"/>
+                <a:gridCol w="3108960">
+                  <a:extLst>
+                    <a:ext uri="{9D8B030D-6E8A-4147-A177-3AD203B41FA5}">
+                      <a16:colId xmlns:a16="http://schemas.microsoft.com/office/drawing/2014/main" val="20000"/>
+                    </a:ext>
+                  </a:extLst>
+                </a:gridCol>
+                <a:gridCol w="8321040">
+                  <a:extLst>
+                    <a:ext uri="{9D8B030D-6E8A-4147-A177-3AD203B41FA5}">
+                      <a16:colId xmlns:a16="http://schemas.microsoft.com/office/drawing/2014/main" val="20001"/>
+                    </a:ext>
+                  </a:extLst>
+                </a:gridCol>
               </a:tblGrid>
               <a:tr h="512064">
                 <a:tc>
                   <a:txBody>
-                    <a:bodyPr wrap="square"/>
+                    <a:bodyPr/>
                     <a:lstStyle/>
                     <a:p>
                       <a:pPr algn="l"/>
@@ -4799,7 +5028,7 @@
                       </a:r>
                     </a:p>
                   </a:txBody>
-                  <a:tcPr anchor="ctr" marL="73152" marR="73152" marT="18288" marB="18288">
+                  <a:tcPr marL="73152" marR="73152" marT="18288" marB="18288" anchor="ctr">
                     <a:solidFill>
                       <a:srgbClr val="E8C77E"/>
                     </a:solidFill>
@@ -4807,7 +5036,7 @@
                 </a:tc>
                 <a:tc>
                   <a:txBody>
-                    <a:bodyPr wrap="square"/>
+                    <a:bodyPr/>
                     <a:lstStyle/>
                     <a:p>
                       <a:pPr algn="l"/>
@@ -4822,17 +5051,22 @@
                       </a:r>
                     </a:p>
                   </a:txBody>
-                  <a:tcPr anchor="ctr" marL="73152" marR="73152" marT="18288" marB="18288">
+                  <a:tcPr marL="73152" marR="73152" marT="18288" marB="18288" anchor="ctr">
                     <a:solidFill>
                       <a:srgbClr val="FFFFFF"/>
                     </a:solidFill>
                   </a:tcPr>
                 </a:tc>
+                <a:extLst>
+                  <a:ext uri="{0D108BD9-81ED-4DB2-BD59-A6C34878D82A}">
+                    <a16:rowId xmlns:a16="http://schemas.microsoft.com/office/drawing/2014/main" val="10000"/>
+                  </a:ext>
+                </a:extLst>
               </a:tr>
               <a:tr h="512064">
                 <a:tc>
                   <a:txBody>
-                    <a:bodyPr wrap="square"/>
+                    <a:bodyPr/>
                     <a:lstStyle/>
                     <a:p>
                       <a:pPr algn="l"/>
@@ -4847,7 +5081,7 @@
                       </a:r>
                     </a:p>
                   </a:txBody>
-                  <a:tcPr anchor="ctr" marL="73152" marR="73152" marT="18288" marB="18288">
+                  <a:tcPr marL="73152" marR="73152" marT="18288" marB="18288" anchor="ctr">
                     <a:solidFill>
                       <a:srgbClr val="E8C77E"/>
                     </a:solidFill>
@@ -4855,7 +5089,7 @@
                 </a:tc>
                 <a:tc>
                   <a:txBody>
-                    <a:bodyPr wrap="square"/>
+                    <a:bodyPr/>
                     <a:lstStyle/>
                     <a:p>
                       <a:pPr algn="l"/>
@@ -4870,17 +5104,22 @@
                       </a:r>
                     </a:p>
                   </a:txBody>
-                  <a:tcPr anchor="ctr" marL="73152" marR="73152" marT="18288" marB="18288">
+                  <a:tcPr marL="73152" marR="73152" marT="18288" marB="18288" anchor="ctr">
                     <a:solidFill>
                       <a:srgbClr val="FFFFFF"/>
                     </a:solidFill>
                   </a:tcPr>
                 </a:tc>
+                <a:extLst>
+                  <a:ext uri="{0D108BD9-81ED-4DB2-BD59-A6C34878D82A}">
+                    <a16:rowId xmlns:a16="http://schemas.microsoft.com/office/drawing/2014/main" val="10001"/>
+                  </a:ext>
+                </a:extLst>
               </a:tr>
               <a:tr h="512064">
                 <a:tc>
                   <a:txBody>
-                    <a:bodyPr wrap="square"/>
+                    <a:bodyPr/>
                     <a:lstStyle/>
                     <a:p>
                       <a:pPr algn="l"/>
@@ -4895,7 +5134,7 @@
                       </a:r>
                     </a:p>
                   </a:txBody>
-                  <a:tcPr anchor="ctr" marL="73152" marR="73152" marT="18288" marB="18288">
+                  <a:tcPr marL="73152" marR="73152" marT="18288" marB="18288" anchor="ctr">
                     <a:solidFill>
                       <a:srgbClr val="E8C77E"/>
                     </a:solidFill>
@@ -4903,7 +5142,7 @@
                 </a:tc>
                 <a:tc>
                   <a:txBody>
-                    <a:bodyPr wrap="square"/>
+                    <a:bodyPr/>
                     <a:lstStyle/>
                     <a:p>
                       <a:pPr algn="l"/>
@@ -4918,17 +5157,22 @@
                       </a:r>
                     </a:p>
                   </a:txBody>
-                  <a:tcPr anchor="ctr" marL="73152" marR="73152" marT="18288" marB="18288">
+                  <a:tcPr marL="73152" marR="73152" marT="18288" marB="18288" anchor="ctr">
                     <a:solidFill>
                       <a:srgbClr val="FFFFFF"/>
                     </a:solidFill>
                   </a:tcPr>
                 </a:tc>
+                <a:extLst>
+                  <a:ext uri="{0D108BD9-81ED-4DB2-BD59-A6C34878D82A}">
+                    <a16:rowId xmlns:a16="http://schemas.microsoft.com/office/drawing/2014/main" val="10002"/>
+                  </a:ext>
+                </a:extLst>
               </a:tr>
               <a:tr h="512064">
                 <a:tc>
                   <a:txBody>
-                    <a:bodyPr wrap="square"/>
+                    <a:bodyPr/>
                     <a:lstStyle/>
                     <a:p>
                       <a:pPr algn="l"/>
@@ -4943,7 +5187,7 @@
                       </a:r>
                     </a:p>
                   </a:txBody>
-                  <a:tcPr anchor="ctr" marL="73152" marR="73152" marT="18288" marB="18288">
+                  <a:tcPr marL="73152" marR="73152" marT="18288" marB="18288" anchor="ctr">
                     <a:solidFill>
                       <a:srgbClr val="E8C77E"/>
                     </a:solidFill>
@@ -4951,7 +5195,7 @@
                 </a:tc>
                 <a:tc>
                   <a:txBody>
-                    <a:bodyPr wrap="square"/>
+                    <a:bodyPr/>
                     <a:lstStyle/>
                     <a:p>
                       <a:pPr algn="l"/>
@@ -4966,12 +5210,17 @@
                       </a:r>
                     </a:p>
                   </a:txBody>
-                  <a:tcPr anchor="ctr" marL="73152" marR="73152" marT="18288" marB="18288">
+                  <a:tcPr marL="73152" marR="73152" marT="18288" marB="18288" anchor="ctr">
                     <a:solidFill>
                       <a:srgbClr val="FFFFFF"/>
                     </a:solidFill>
                   </a:tcPr>
                 </a:tc>
+                <a:extLst>
+                  <a:ext uri="{0D108BD9-81ED-4DB2-BD59-A6C34878D82A}">
+                    <a16:rowId xmlns:a16="http://schemas.microsoft.com/office/drawing/2014/main" val="10003"/>
+                  </a:ext>
+                </a:extLst>
               </a:tr>
             </a:tbl>
           </a:graphicData>
@@ -4994,7 +5243,7 @@
           <a:noFill/>
         </p:spPr>
         <p:txBody>
-          <a:bodyPr wrap="square" lIns="0" rIns="0" tIns="0" bIns="0">
+          <a:bodyPr wrap="square" lIns="0" tIns="0" rIns="0" bIns="0">
             <a:spAutoFit/>
           </a:bodyPr>
           <a:lstStyle/>
@@ -5018,7 +5267,13 @@
           <p:cNvGraphicFramePr>
             <a:graphicFrameLocks noGrp="1"/>
           </p:cNvGraphicFramePr>
-          <p:nvPr/>
+          <p:nvPr>
+            <p:extLst>
+              <p:ext uri="{D42A27DB-BD31-4B8C-83A1-F6EECF244321}">
+                <p14:modId xmlns:p14="http://schemas.microsoft.com/office/powerpoint/2010/main" val="2098144094"/>
+              </p:ext>
+            </p:extLst>
+          </p:nvPr>
         </p:nvGraphicFramePr>
         <p:xfrm>
           <a:off x="384048" y="3639312"/>
@@ -5031,14 +5286,32 @@
                 <a:tableStyleId>{5C22544A-7EE6-4342-B048-85BDC9FD1C3A}</a:tableStyleId>
               </a:tblPr>
               <a:tblGrid>
-                <a:gridCol w="640080"/>
-                <a:gridCol w="8138160"/>
-                <a:gridCol w="2651760"/>
+                <a:gridCol w="640080">
+                  <a:extLst>
+                    <a:ext uri="{9D8B030D-6E8A-4147-A177-3AD203B41FA5}">
+                      <a16:colId xmlns:a16="http://schemas.microsoft.com/office/drawing/2014/main" val="20000"/>
+                    </a:ext>
+                  </a:extLst>
+                </a:gridCol>
+                <a:gridCol w="8138160">
+                  <a:extLst>
+                    <a:ext uri="{9D8B030D-6E8A-4147-A177-3AD203B41FA5}">
+                      <a16:colId xmlns:a16="http://schemas.microsoft.com/office/drawing/2014/main" val="20001"/>
+                    </a:ext>
+                  </a:extLst>
+                </a:gridCol>
+                <a:gridCol w="2651760">
+                  <a:extLst>
+                    <a:ext uri="{9D8B030D-6E8A-4147-A177-3AD203B41FA5}">
+                      <a16:colId xmlns:a16="http://schemas.microsoft.com/office/drawing/2014/main" val="20002"/>
+                    </a:ext>
+                  </a:extLst>
+                </a:gridCol>
               </a:tblGrid>
               <a:tr h="384048">
                 <a:tc>
                   <a:txBody>
-                    <a:bodyPr wrap="square"/>
+                    <a:bodyPr/>
                     <a:lstStyle/>
                     <a:p>
                       <a:pPr algn="l"/>
@@ -5053,7 +5326,7 @@
                       </a:r>
                     </a:p>
                   </a:txBody>
-                  <a:tcPr anchor="ctr" marL="73152" marR="73152" marT="18288" marB="18288">
+                  <a:tcPr marL="73152" marR="73152" marT="18288" marB="18288" anchor="ctr">
                     <a:solidFill>
                       <a:srgbClr val="16233F"/>
                     </a:solidFill>
@@ -5061,7 +5334,7 @@
                 </a:tc>
                 <a:tc>
                   <a:txBody>
-                    <a:bodyPr wrap="square"/>
+                    <a:bodyPr/>
                     <a:lstStyle/>
                     <a:p>
                       <a:pPr algn="l"/>
@@ -5076,7 +5349,7 @@
                       </a:r>
                     </a:p>
                   </a:txBody>
-                  <a:tcPr anchor="ctr" marL="73152" marR="73152" marT="18288" marB="18288">
+                  <a:tcPr marL="73152" marR="73152" marT="18288" marB="18288" anchor="ctr">
                     <a:solidFill>
                       <a:srgbClr val="16233F"/>
                     </a:solidFill>
@@ -5084,7 +5357,7 @@
                 </a:tc>
                 <a:tc>
                   <a:txBody>
-                    <a:bodyPr wrap="square"/>
+                    <a:bodyPr/>
                     <a:lstStyle/>
                     <a:p>
                       <a:pPr algn="l"/>
@@ -5099,17 +5372,22 @@
                       </a:r>
                     </a:p>
                   </a:txBody>
-                  <a:tcPr anchor="ctr" marL="73152" marR="73152" marT="18288" marB="18288">
+                  <a:tcPr marL="73152" marR="73152" marT="18288" marB="18288" anchor="ctr">
                     <a:solidFill>
                       <a:srgbClr val="16233F"/>
                     </a:solidFill>
                   </a:tcPr>
                 </a:tc>
+                <a:extLst>
+                  <a:ext uri="{0D108BD9-81ED-4DB2-BD59-A6C34878D82A}">
+                    <a16:rowId xmlns:a16="http://schemas.microsoft.com/office/drawing/2014/main" val="10000"/>
+                  </a:ext>
+                </a:extLst>
               </a:tr>
               <a:tr h="384048">
                 <a:tc>
                   <a:txBody>
-                    <a:bodyPr wrap="square"/>
+                    <a:bodyPr/>
                     <a:lstStyle/>
                     <a:p>
                       <a:pPr algn="ctr"/>
@@ -5124,7 +5402,7 @@
                       </a:r>
                     </a:p>
                   </a:txBody>
-                  <a:tcPr anchor="ctr" marL="73152" marR="73152" marT="18288" marB="18288">
+                  <a:tcPr marL="73152" marR="73152" marT="18288" marB="18288" anchor="ctr">
                     <a:solidFill>
                       <a:srgbClr val="FFFFFF"/>
                     </a:solidFill>
@@ -5132,7 +5410,7 @@
                 </a:tc>
                 <a:tc>
                   <a:txBody>
-                    <a:bodyPr wrap="square"/>
+                    <a:bodyPr/>
                     <a:lstStyle/>
                     <a:p>
                       <a:pPr algn="l"/>
@@ -5147,7 +5425,7 @@
                       </a:r>
                     </a:p>
                   </a:txBody>
-                  <a:tcPr anchor="ctr" marL="73152" marR="73152" marT="18288" marB="18288">
+                  <a:tcPr marL="73152" marR="73152" marT="18288" marB="18288" anchor="ctr">
                     <a:solidFill>
                       <a:srgbClr val="FFFFFF"/>
                     </a:solidFill>
@@ -5155,7 +5433,7 @@
                 </a:tc>
                 <a:tc>
                   <a:txBody>
-                    <a:bodyPr wrap="square"/>
+                    <a:bodyPr/>
                     <a:lstStyle/>
                     <a:p>
                       <a:pPr algn="l"/>
@@ -5170,17 +5448,22 @@
                       </a:r>
                     </a:p>
                   </a:txBody>
-                  <a:tcPr anchor="ctr" marL="73152" marR="73152" marT="18288" marB="18288">
+                  <a:tcPr marL="73152" marR="73152" marT="18288" marB="18288" anchor="ctr">
                     <a:solidFill>
                       <a:srgbClr val="FFFFFF"/>
                     </a:solidFill>
                   </a:tcPr>
                 </a:tc>
+                <a:extLst>
+                  <a:ext uri="{0D108BD9-81ED-4DB2-BD59-A6C34878D82A}">
+                    <a16:rowId xmlns:a16="http://schemas.microsoft.com/office/drawing/2014/main" val="10001"/>
+                  </a:ext>
+                </a:extLst>
               </a:tr>
               <a:tr h="384048">
                 <a:tc>
                   <a:txBody>
-                    <a:bodyPr wrap="square"/>
+                    <a:bodyPr/>
                     <a:lstStyle/>
                     <a:p>
                       <a:pPr algn="ctr"/>
@@ -5195,7 +5478,7 @@
                       </a:r>
                     </a:p>
                   </a:txBody>
-                  <a:tcPr anchor="ctr" marL="73152" marR="73152" marT="18288" marB="18288">
+                  <a:tcPr marL="73152" marR="73152" marT="18288" marB="18288" anchor="ctr">
                     <a:solidFill>
                       <a:srgbClr val="F2F6FB"/>
                     </a:solidFill>
@@ -5203,7 +5486,7 @@
                 </a:tc>
                 <a:tc>
                   <a:txBody>
-                    <a:bodyPr wrap="square"/>
+                    <a:bodyPr/>
                     <a:lstStyle/>
                     <a:p>
                       <a:pPr algn="l"/>
@@ -5218,7 +5501,7 @@
                       </a:r>
                     </a:p>
                   </a:txBody>
-                  <a:tcPr anchor="ctr" marL="73152" marR="73152" marT="18288" marB="18288">
+                  <a:tcPr marL="73152" marR="73152" marT="18288" marB="18288" anchor="ctr">
                     <a:solidFill>
                       <a:srgbClr val="F2F6FB"/>
                     </a:solidFill>
@@ -5226,7 +5509,7 @@
                 </a:tc>
                 <a:tc>
                   <a:txBody>
-                    <a:bodyPr wrap="square"/>
+                    <a:bodyPr/>
                     <a:lstStyle/>
                     <a:p>
                       <a:pPr algn="l"/>
@@ -5241,17 +5524,22 @@
                       </a:r>
                     </a:p>
                   </a:txBody>
-                  <a:tcPr anchor="ctr" marL="73152" marR="73152" marT="18288" marB="18288">
+                  <a:tcPr marL="73152" marR="73152" marT="18288" marB="18288" anchor="ctr">
                     <a:solidFill>
                       <a:srgbClr val="F2F6FB"/>
                     </a:solidFill>
                   </a:tcPr>
                 </a:tc>
+                <a:extLst>
+                  <a:ext uri="{0D108BD9-81ED-4DB2-BD59-A6C34878D82A}">
+                    <a16:rowId xmlns:a16="http://schemas.microsoft.com/office/drawing/2014/main" val="10002"/>
+                  </a:ext>
+                </a:extLst>
               </a:tr>
               <a:tr h="384048">
                 <a:tc>
                   <a:txBody>
-                    <a:bodyPr wrap="square"/>
+                    <a:bodyPr/>
                     <a:lstStyle/>
                     <a:p>
                       <a:pPr algn="ctr"/>
@@ -5266,7 +5554,7 @@
                       </a:r>
                     </a:p>
                   </a:txBody>
-                  <a:tcPr anchor="ctr" marL="73152" marR="73152" marT="18288" marB="18288">
+                  <a:tcPr marL="73152" marR="73152" marT="18288" marB="18288" anchor="ctr">
                     <a:solidFill>
                       <a:srgbClr val="FFFFFF"/>
                     </a:solidFill>
@@ -5274,7 +5562,7 @@
                 </a:tc>
                 <a:tc>
                   <a:txBody>
-                    <a:bodyPr wrap="square"/>
+                    <a:bodyPr/>
                     <a:lstStyle/>
                     <a:p>
                       <a:pPr algn="l"/>
@@ -5289,7 +5577,7 @@
                       </a:r>
                     </a:p>
                   </a:txBody>
-                  <a:tcPr anchor="ctr" marL="73152" marR="73152" marT="18288" marB="18288">
+                  <a:tcPr marL="73152" marR="73152" marT="18288" marB="18288" anchor="ctr">
                     <a:solidFill>
                       <a:srgbClr val="FFFFFF"/>
                     </a:solidFill>
@@ -5297,32 +5585,53 @@
                 </a:tc>
                 <a:tc>
                   <a:txBody>
-                    <a:bodyPr wrap="square"/>
+                    <a:bodyPr/>
                     <a:lstStyle/>
                     <a:p>
-                      <a:pPr algn="l"/>
+                      <a:pPr marL="0" marR="0" lvl="0" indent="0" algn="l" defTabSz="457200" rtl="0" eaLnBrk="1" fontAlgn="auto" latinLnBrk="0" hangingPunct="1">
+                        <a:lnSpc>
+                          <a:spcPct val="100000"/>
+                        </a:lnSpc>
+                        <a:spcBef>
+                          <a:spcPts val="0"/>
+                        </a:spcBef>
+                        <a:spcAft>
+                          <a:spcPts val="0"/>
+                        </a:spcAft>
+                        <a:buClrTx/>
+                        <a:buSzTx/>
+                        <a:buFontTx/>
+                        <a:buNone/>
+                        <a:tabLst/>
+                        <a:defRPr/>
+                      </a:pPr>
                       <a:r>
-                        <a:rPr sz="950" b="1">
+                        <a:rPr lang="en-PH" sz="950" b="1" dirty="0">
                           <a:solidFill>
-                            <a:srgbClr val="1F4E79"/>
+                            <a:srgbClr val="1F7A3D"/>
                           </a:solidFill>
-                          <a:latin typeface="Calibri"/>
+                          <a:latin typeface="+mn-lt"/>
                         </a:rPr>
-                        <a:t>released separately</a:t>
+                        <a:t>yes</a:t>
                       </a:r>
                     </a:p>
                   </a:txBody>
-                  <a:tcPr anchor="ctr" marL="73152" marR="73152" marT="18288" marB="18288">
+                  <a:tcPr marL="73152" marR="73152" marT="18288" marB="18288" anchor="ctr">
                     <a:solidFill>
                       <a:srgbClr val="FFFFFF"/>
                     </a:solidFill>
                   </a:tcPr>
                 </a:tc>
+                <a:extLst>
+                  <a:ext uri="{0D108BD9-81ED-4DB2-BD59-A6C34878D82A}">
+                    <a16:rowId xmlns:a16="http://schemas.microsoft.com/office/drawing/2014/main" val="10003"/>
+                  </a:ext>
+                </a:extLst>
               </a:tr>
               <a:tr h="384048">
                 <a:tc>
                   <a:txBody>
-                    <a:bodyPr wrap="square"/>
+                    <a:bodyPr/>
                     <a:lstStyle/>
                     <a:p>
                       <a:pPr algn="ctr"/>
@@ -5337,7 +5646,7 @@
                       </a:r>
                     </a:p>
                   </a:txBody>
-                  <a:tcPr anchor="ctr" marL="73152" marR="73152" marT="18288" marB="18288">
+                  <a:tcPr marL="73152" marR="73152" marT="18288" marB="18288" anchor="ctr">
                     <a:solidFill>
                       <a:srgbClr val="F2F6FB"/>
                     </a:solidFill>
@@ -5345,7 +5654,7 @@
                 </a:tc>
                 <a:tc>
                   <a:txBody>
-                    <a:bodyPr wrap="square"/>
+                    <a:bodyPr/>
                     <a:lstStyle/>
                     <a:p>
                       <a:pPr algn="l"/>
@@ -5360,7 +5669,7 @@
                       </a:r>
                     </a:p>
                   </a:txBody>
-                  <a:tcPr anchor="ctr" marL="73152" marR="73152" marT="18288" marB="18288">
+                  <a:tcPr marL="73152" marR="73152" marT="18288" marB="18288" anchor="ctr">
                     <a:solidFill>
                       <a:srgbClr val="F2F6FB"/>
                     </a:solidFill>
@@ -5368,7 +5677,83 @@
                 </a:tc>
                 <a:tc>
                   <a:txBody>
-                    <a:bodyPr wrap="square"/>
+                    <a:bodyPr/>
+                    <a:lstStyle/>
+                    <a:p>
+                      <a:pPr algn="l"/>
+                      <a:r>
+                        <a:rPr sz="950" b="1" dirty="0">
+                          <a:solidFill>
+                            <a:srgbClr val="1F7A3D"/>
+                          </a:solidFill>
+                          <a:latin typeface="Calibri"/>
+                        </a:rPr>
+                        <a:t>yes</a:t>
+                      </a:r>
+                    </a:p>
+                  </a:txBody>
+                  <a:tcPr marL="73152" marR="73152" marT="18288" marB="18288" anchor="ctr">
+                    <a:solidFill>
+                      <a:srgbClr val="F2F6FB"/>
+                    </a:solidFill>
+                  </a:tcPr>
+                </a:tc>
+                <a:extLst>
+                  <a:ext uri="{0D108BD9-81ED-4DB2-BD59-A6C34878D82A}">
+                    <a16:rowId xmlns:a16="http://schemas.microsoft.com/office/drawing/2014/main" val="10004"/>
+                  </a:ext>
+                </a:extLst>
+              </a:tr>
+              <a:tr h="384048">
+                <a:tc>
+                  <a:txBody>
+                    <a:bodyPr/>
+                    <a:lstStyle/>
+                    <a:p>
+                      <a:pPr algn="ctr"/>
+                      <a:r>
+                        <a:rPr sz="950" b="0">
+                          <a:solidFill>
+                            <a:srgbClr val="1A1A1A"/>
+                          </a:solidFill>
+                          <a:latin typeface="Calibri"/>
+                        </a:rPr>
+                        <a:t>5</a:t>
+                      </a:r>
+                    </a:p>
+                  </a:txBody>
+                  <a:tcPr marL="73152" marR="73152" marT="18288" marB="18288" anchor="ctr">
+                    <a:solidFill>
+                      <a:srgbClr val="FFFFFF"/>
+                    </a:solidFill>
+                  </a:tcPr>
+                </a:tc>
+                <a:tc>
+                  <a:txBody>
+                    <a:bodyPr/>
+                    <a:lstStyle/>
+                    <a:p>
+                      <a:pPr algn="l"/>
+                      <a:r>
+                        <a:rPr sz="950" b="0">
+                          <a:solidFill>
+                            <a:srgbClr val="1A1A1A"/>
+                          </a:solidFill>
+                          <a:latin typeface="Calibri"/>
+                        </a:rPr>
+                        <a:t>Held-out test set, unseen speakers</a:t>
+                      </a:r>
+                    </a:p>
+                  </a:txBody>
+                  <a:tcPr marL="73152" marR="73152" marT="18288" marB="18288" anchor="ctr">
+                    <a:solidFill>
+                      <a:srgbClr val="FFFFFF"/>
+                    </a:solidFill>
+                  </a:tcPr>
+                </a:tc>
+                <a:tc>
+                  <a:txBody>
+                    <a:bodyPr/>
                     <a:lstStyle/>
                     <a:p>
                       <a:pPr algn="l"/>
@@ -5383,88 +5768,22 @@
                       </a:r>
                     </a:p>
                   </a:txBody>
-                  <a:tcPr anchor="ctr" marL="73152" marR="73152" marT="18288" marB="18288">
-                    <a:solidFill>
-                      <a:srgbClr val="F2F6FB"/>
-                    </a:solidFill>
-                  </a:tcPr>
-                </a:tc>
-              </a:tr>
-              <a:tr h="384048">
-                <a:tc>
-                  <a:txBody>
-                    <a:bodyPr wrap="square"/>
-                    <a:lstStyle/>
-                    <a:p>
-                      <a:pPr algn="ctr"/>
-                      <a:r>
-                        <a:rPr sz="950" b="0">
-                          <a:solidFill>
-                            <a:srgbClr val="1A1A1A"/>
-                          </a:solidFill>
-                          <a:latin typeface="Calibri"/>
-                        </a:rPr>
-                        <a:t>5</a:t>
-                      </a:r>
-                    </a:p>
-                  </a:txBody>
-                  <a:tcPr anchor="ctr" marL="73152" marR="73152" marT="18288" marB="18288">
+                  <a:tcPr marL="73152" marR="73152" marT="18288" marB="18288" anchor="ctr">
                     <a:solidFill>
                       <a:srgbClr val="FFFFFF"/>
                     </a:solidFill>
                   </a:tcPr>
                 </a:tc>
-                <a:tc>
-                  <a:txBody>
-                    <a:bodyPr wrap="square"/>
-                    <a:lstStyle/>
-                    <a:p>
-                      <a:pPr algn="l"/>
-                      <a:r>
-                        <a:rPr sz="950" b="0">
-                          <a:solidFill>
-                            <a:srgbClr val="1A1A1A"/>
-                          </a:solidFill>
-                          <a:latin typeface="Calibri"/>
-                        </a:rPr>
-                        <a:t>Held-out test set, unseen speakers</a:t>
-                      </a:r>
-                    </a:p>
-                  </a:txBody>
-                  <a:tcPr anchor="ctr" marL="73152" marR="73152" marT="18288" marB="18288">
-                    <a:solidFill>
-                      <a:srgbClr val="FFFFFF"/>
-                    </a:solidFill>
-                  </a:tcPr>
-                </a:tc>
-                <a:tc>
-                  <a:txBody>
-                    <a:bodyPr wrap="square"/>
-                    <a:lstStyle/>
-                    <a:p>
-                      <a:pPr algn="l"/>
-                      <a:r>
-                        <a:rPr sz="950" b="1">
-                          <a:solidFill>
-                            <a:srgbClr val="1F7A3D"/>
-                          </a:solidFill>
-                          <a:latin typeface="Calibri"/>
-                        </a:rPr>
-                        <a:t>yes</a:t>
-                      </a:r>
-                    </a:p>
-                  </a:txBody>
-                  <a:tcPr anchor="ctr" marL="73152" marR="73152" marT="18288" marB="18288">
-                    <a:solidFill>
-                      <a:srgbClr val="FFFFFF"/>
-                    </a:solidFill>
-                  </a:tcPr>
-                </a:tc>
+                <a:extLst>
+                  <a:ext uri="{0D108BD9-81ED-4DB2-BD59-A6C34878D82A}">
+                    <a16:rowId xmlns:a16="http://schemas.microsoft.com/office/drawing/2014/main" val="10005"/>
+                  </a:ext>
+                </a:extLst>
               </a:tr>
               <a:tr h="384048">
                 <a:tc>
                   <a:txBody>
-                    <a:bodyPr wrap="square"/>
+                    <a:bodyPr/>
                     <a:lstStyle/>
                     <a:p>
                       <a:pPr algn="ctr"/>
@@ -5479,7 +5798,7 @@
                       </a:r>
                     </a:p>
                   </a:txBody>
-                  <a:tcPr anchor="ctr" marL="73152" marR="73152" marT="18288" marB="18288">
+                  <a:tcPr marL="73152" marR="73152" marT="18288" marB="18288" anchor="ctr">
                     <a:solidFill>
                       <a:srgbClr val="F2F6FB"/>
                     </a:solidFill>
@@ -5487,7 +5806,7 @@
                 </a:tc>
                 <a:tc>
                   <a:txBody>
-                    <a:bodyPr wrap="square"/>
+                    <a:bodyPr/>
                     <a:lstStyle/>
                     <a:p>
                       <a:pPr algn="l"/>
@@ -5502,7 +5821,7 @@
                       </a:r>
                     </a:p>
                   </a:txBody>
-                  <a:tcPr anchor="ctr" marL="73152" marR="73152" marT="18288" marB="18288">
+                  <a:tcPr marL="73152" marR="73152" marT="18288" marB="18288" anchor="ctr">
                     <a:solidFill>
                       <a:srgbClr val="F2F6FB"/>
                     </a:solidFill>
@@ -5510,12 +5829,12 @@
                 </a:tc>
                 <a:tc>
                   <a:txBody>
-                    <a:bodyPr wrap="square"/>
+                    <a:bodyPr/>
                     <a:lstStyle/>
                     <a:p>
                       <a:pPr algn="l"/>
                       <a:r>
-                        <a:rPr sz="950" b="1">
+                        <a:rPr sz="950" b="1" dirty="0">
                           <a:solidFill>
                             <a:srgbClr val="1F7A3D"/>
                           </a:solidFill>
@@ -5525,12 +5844,17 @@
                       </a:r>
                     </a:p>
                   </a:txBody>
-                  <a:tcPr anchor="ctr" marL="73152" marR="73152" marT="18288" marB="18288">
+                  <a:tcPr marL="73152" marR="73152" marT="18288" marB="18288" anchor="ctr">
                     <a:solidFill>
                       <a:srgbClr val="F2F6FB"/>
                     </a:solidFill>
                   </a:tcPr>
                 </a:tc>
+                <a:extLst>
+                  <a:ext uri="{0D108BD9-81ED-4DB2-BD59-A6C34878D82A}">
+                    <a16:rowId xmlns:a16="http://schemas.microsoft.com/office/drawing/2014/main" val="10006"/>
+                  </a:ext>
+                </a:extLst>
               </a:tr>
             </a:tbl>
           </a:graphicData>
@@ -5545,7 +5869,7 @@
 </file>
 
 <file path=ppt/slides/slide3.xml><?xml version="1.0" encoding="utf-8"?>
-<p:sld xmlns:a="http://schemas.openxmlformats.org/drawingml/2006/main" xmlns:p="http://schemas.openxmlformats.org/presentationml/2006/main" xmlns:r="http://schemas.openxmlformats.org/officeDocument/2006/relationships">
+<p:sld xmlns:a="http://schemas.openxmlformats.org/drawingml/2006/main" xmlns:r="http://schemas.openxmlformats.org/officeDocument/2006/relationships" xmlns:p="http://schemas.openxmlformats.org/presentationml/2006/main">
   <p:cSld>
     <p:spTree>
       <p:nvGrpSpPr>
@@ -5553,7 +5877,14 @@
         <p:cNvGrpSpPr/>
         <p:nvPr/>
       </p:nvGrpSpPr>
-      <p:grpSpPr/>
+      <p:grpSpPr>
+        <a:xfrm>
+          <a:off x="0" y="0"/>
+          <a:ext cx="0" cy="0"/>
+          <a:chOff x="0" y="0"/>
+          <a:chExt cx="0" cy="0"/>
+        </a:xfrm>
+      </p:grpSpPr>
       <p:sp>
         <p:nvSpPr>
           <p:cNvPr id="2" name="TextBox 1"/>
@@ -5571,7 +5902,7 @@
           <a:noFill/>
         </p:spPr>
         <p:txBody>
-          <a:bodyPr wrap="square" lIns="0" rIns="0" tIns="0" bIns="0">
+          <a:bodyPr wrap="square" lIns="0" tIns="0" rIns="0" bIns="0">
             <a:spAutoFit/>
           </a:bodyPr>
           <a:lstStyle/>
@@ -5606,7 +5937,7 @@
           <a:noFill/>
         </p:spPr>
         <p:txBody>
-          <a:bodyPr wrap="square" lIns="0" rIns="0" tIns="0" bIns="0">
+          <a:bodyPr wrap="square" lIns="0" tIns="0" rIns="0" bIns="0">
             <a:spAutoFit/>
           </a:bodyPr>
           <a:lstStyle/>
@@ -5641,7 +5972,7 @@
           <a:noFill/>
         </p:spPr>
         <p:txBody>
-          <a:bodyPr wrap="square" lIns="0" rIns="0" tIns="0" bIns="0">
+          <a:bodyPr wrap="square" lIns="0" tIns="0" rIns="0" bIns="0">
             <a:spAutoFit/>
           </a:bodyPr>
           <a:lstStyle/>
@@ -5676,7 +6007,7 @@
           <a:noFill/>
         </p:spPr>
         <p:txBody>
-          <a:bodyPr wrap="square" lIns="0" rIns="0" tIns="0" bIns="0">
+          <a:bodyPr wrap="square" lIns="0" tIns="0" rIns="0" bIns="0">
             <a:spAutoFit/>
           </a:bodyPr>
           <a:lstStyle/>
@@ -5711,7 +6042,7 @@
           <a:noFill/>
         </p:spPr>
         <p:txBody>
-          <a:bodyPr wrap="square" lIns="0" rIns="0" tIns="0" bIns="0">
+          <a:bodyPr wrap="square" lIns="0" tIns="0" rIns="0" bIns="0">
             <a:spAutoFit/>
           </a:bodyPr>
           <a:lstStyle/>
@@ -5746,7 +6077,7 @@
           <a:noFill/>
         </p:spPr>
         <p:txBody>
-          <a:bodyPr wrap="square" lIns="0" rIns="0" tIns="0" bIns="0">
+          <a:bodyPr wrap="square" lIns="0" tIns="0" rIns="0" bIns="0">
             <a:spAutoFit/>
           </a:bodyPr>
           <a:lstStyle/>
@@ -5781,7 +6112,7 @@
           <a:noFill/>
         </p:spPr>
         <p:txBody>
-          <a:bodyPr wrap="square" lIns="0" rIns="0" tIns="0" bIns="0">
+          <a:bodyPr wrap="square" lIns="0" tIns="0" rIns="0" bIns="0">
             <a:spAutoFit/>
           </a:bodyPr>
           <a:lstStyle/>
@@ -5816,7 +6147,7 @@
           <a:noFill/>
         </p:spPr>
         <p:txBody>
-          <a:bodyPr wrap="square" lIns="0" rIns="0" tIns="0" bIns="0">
+          <a:bodyPr wrap="square" lIns="0" tIns="0" rIns="0" bIns="0">
             <a:spAutoFit/>
           </a:bodyPr>
           <a:lstStyle/>
@@ -5851,7 +6182,7 @@
           <a:noFill/>
         </p:spPr>
         <p:txBody>
-          <a:bodyPr wrap="square" lIns="0" rIns="0" tIns="0" bIns="0">
+          <a:bodyPr wrap="square" lIns="0" tIns="0" rIns="0" bIns="0">
             <a:spAutoFit/>
           </a:bodyPr>
           <a:lstStyle/>
@@ -5886,7 +6217,7 @@
           <a:noFill/>
         </p:spPr>
         <p:txBody>
-          <a:bodyPr wrap="square" lIns="0" rIns="0" tIns="0" bIns="0">
+          <a:bodyPr wrap="square" lIns="0" tIns="0" rIns="0" bIns="0">
             <a:spAutoFit/>
           </a:bodyPr>
           <a:lstStyle/>
@@ -5921,7 +6252,7 @@
           <a:noFill/>
         </p:spPr>
         <p:txBody>
-          <a:bodyPr wrap="square" lIns="0" rIns="0" tIns="0" bIns="0">
+          <a:bodyPr wrap="square" lIns="0" tIns="0" rIns="0" bIns="0">
             <a:spAutoFit/>
           </a:bodyPr>
           <a:lstStyle/>
@@ -5956,7 +6287,7 @@
           <a:noFill/>
         </p:spPr>
         <p:txBody>
-          <a:bodyPr wrap="square" lIns="0" rIns="0" tIns="0" bIns="0">
+          <a:bodyPr wrap="square" lIns="0" tIns="0" rIns="0" bIns="0">
             <a:spAutoFit/>
           </a:bodyPr>
           <a:lstStyle/>

</xml_diff>